<commit_message>
feat: redesign app for visual model education
</commit_message>
<xml_diff>
--- a/presentation/diabetes_ensemble_presentation.pptx
+++ b/presentation/diabetes_ensemble_presentation.pptx
@@ -3087,7 +3087,7 @@
     <p:bg>
       <p:bgPr>
         <a:solidFill>
-          <a:srgbClr val="172D3A"/>
+          <a:srgbClr val="E5E8E1"/>
         </a:solidFill>
         <a:effectLst/>
       </p:bgPr>
@@ -3107,8 +3107,8 @@
         </p:nvSpPr>
         <p:spPr>
           <a:xfrm>
-            <a:off x="640080" y="658368"/>
-            <a:ext cx="4114800" cy="274320"/>
+            <a:off x="502920" y="256032"/>
+            <a:ext cx="2926080" cy="182880"/>
           </a:xfrm>
           <a:prstGeom prst="rect">
             <a:avLst/>
@@ -3123,13 +3123,13 @@
           <a:p>
             <a:pPr algn="l"/>
             <a:r>
-              <a:rPr sz="1000" b="1">
-                <a:solidFill>
-                  <a:srgbClr val="E7F6F3"/>
+              <a:rPr sz="800" b="1">
+                <a:solidFill>
+                  <a:srgbClr val="05685F"/>
                 </a:solidFill>
                 <a:latin typeface="Aptos"/>
               </a:rPr>
-              <a:t>ENSEMBLE MODELING STUDY</a:t>
+              <a:t>DIABETES MODEL STUDY</a:t>
             </a:r>
           </a:p>
         </p:txBody>
@@ -3142,8 +3142,8 @@
         </p:nvSpPr>
         <p:spPr>
           <a:xfrm>
-            <a:off x="640080" y="1325880"/>
-            <a:ext cx="7040880" cy="1554480"/>
+            <a:off x="8229600" y="256032"/>
+            <a:ext cx="3200400" cy="182880"/>
           </a:xfrm>
           <a:prstGeom prst="rect">
             <a:avLst/>
@@ -3156,16 +3156,15 @@
           </a:bodyPr>
           <a:lstStyle/>
           <a:p>
-            <a:pPr algn="l"/>
-            <a:r>
-              <a:rPr sz="3100" b="1">
-                <a:solidFill>
-                  <a:srgbClr val="FFFFFF"/>
+            <a:pPr algn="r"/>
+            <a:r>
+              <a:rPr sz="800" b="0">
+                <a:solidFill>
+                  <a:srgbClr val="35514C"/>
                 </a:solidFill>
                 <a:latin typeface="Aptos"/>
               </a:rPr>
-              <a:t>Predicting diabetes
-with two powerful lenses.</a:t>
+              <a:t>Overview</a:t>
             </a:r>
           </a:p>
         </p:txBody>
@@ -3178,8 +3177,8 @@
         </p:nvSpPr>
         <p:spPr>
           <a:xfrm>
-            <a:off x="658368" y="3200400"/>
-            <a:ext cx="4754880" cy="365760"/>
+            <a:off x="10972800" y="6519672"/>
+            <a:ext cx="685800" cy="164592"/>
           </a:xfrm>
           <a:prstGeom prst="rect">
             <a:avLst/>
@@ -3192,15 +3191,15 @@
           </a:bodyPr>
           <a:lstStyle/>
           <a:p>
-            <a:pPr algn="l"/>
-            <a:r>
-              <a:rPr sz="1500" b="0">
-                <a:solidFill>
-                  <a:srgbClr val="E7F6F3"/>
+            <a:pPr algn="r"/>
+            <a:r>
+              <a:rPr sz="800" b="1">
+                <a:solidFill>
+                  <a:srgbClr val="35514C"/>
                 </a:solidFill>
                 <a:latin typeface="Aptos"/>
               </a:rPr>
-              <a:t>Random Forest  ×  Gradient Boosting</a:t>
+              <a:t>01 / 04</a:t>
             </a:r>
           </a:p>
         </p:txBody>
@@ -3213,8 +3212,8 @@
         </p:nvSpPr>
         <p:spPr>
           <a:xfrm>
-            <a:off x="658368" y="3840480"/>
-            <a:ext cx="5486400" cy="731520"/>
+            <a:off x="502920" y="6519672"/>
+            <a:ext cx="4114800" cy="164592"/>
           </a:xfrm>
           <a:prstGeom prst="rect">
             <a:avLst/>
@@ -3229,37 +3228,143 @@
           <a:p>
             <a:pPr algn="l"/>
             <a:r>
-              <a:rPr sz="1200" b="0">
-                <a:solidFill>
-                  <a:srgbClr val="FFFFFF"/>
+              <a:rPr sz="800" b="0">
+                <a:solidFill>
+                  <a:srgbClr val="35514C"/>
                 </a:solidFill>
                 <a:latin typeface="Aptos"/>
               </a:rPr>
-              <a:t>A concise comparison of preprocessing, tuning, evaluation, and real-world interpretation using the faculty-approved Kaggle dataset.</a:t>
-            </a:r>
-          </a:p>
-        </p:txBody>
-      </p:sp>
-      <p:sp>
-        <p:nvSpPr>
-          <p:cNvPr id="6" name="Oval 5"/>
+              <a:t>Working Next.js prototype · educational use only</a:t>
+            </a:r>
+          </a:p>
+        </p:txBody>
+      </p:sp>
+      <p:sp>
+        <p:nvSpPr>
+          <p:cNvPr id="6" name="TextBox 5"/>
+          <p:cNvSpPr txBox="1"/>
+          <p:nvPr/>
+        </p:nvSpPr>
+        <p:spPr>
+          <a:xfrm>
+            <a:off x="502920" y="960120"/>
+            <a:ext cx="3749039" cy="1143000"/>
+          </a:xfrm>
+          <a:prstGeom prst="rect">
+            <a:avLst/>
+          </a:prstGeom>
+          <a:noFill/>
+        </p:spPr>
+        <p:txBody>
+          <a:bodyPr wrap="none" lIns="18288" rIns="18288" anchor="ctr">
+            <a:spAutoFit/>
+          </a:bodyPr>
+          <a:lstStyle/>
+          <a:p>
+            <a:pPr algn="l"/>
+            <a:r>
+              <a:rPr sz="2900" b="0">
+                <a:solidFill>
+                  <a:srgbClr val="172F2D"/>
+                </a:solidFill>
+                <a:latin typeface="Georgia"/>
+              </a:rPr>
+              <a:t>The app starts
+with one question.</a:t>
+            </a:r>
+          </a:p>
+        </p:txBody>
+      </p:sp>
+      <p:sp>
+        <p:nvSpPr>
+          <p:cNvPr id="7" name="TextBox 6"/>
+          <p:cNvSpPr txBox="1"/>
+          <p:nvPr/>
+        </p:nvSpPr>
+        <p:spPr>
+          <a:xfrm>
+            <a:off x="530352" y="2322576"/>
+            <a:ext cx="3474720" cy="384048"/>
+          </a:xfrm>
+          <a:prstGeom prst="rect">
+            <a:avLst/>
+          </a:prstGeom>
+          <a:noFill/>
+        </p:spPr>
+        <p:txBody>
+          <a:bodyPr wrap="none" lIns="18288" rIns="18288" anchor="ctr">
+            <a:spAutoFit/>
+          </a:bodyPr>
+          <a:lstStyle/>
+          <a:p>
+            <a:pPr algn="l"/>
+            <a:r>
+              <a:rPr sz="1500" b="1">
+                <a:solidFill>
+                  <a:srgbClr val="05685F"/>
+                </a:solidFill>
+                <a:latin typeface="Aptos"/>
+              </a:rPr>
+              <a:t>What do these models see?</a:t>
+            </a:r>
+          </a:p>
+        </p:txBody>
+      </p:sp>
+      <p:sp>
+        <p:nvSpPr>
+          <p:cNvPr id="8" name="TextBox 7"/>
+          <p:cNvSpPr txBox="1"/>
+          <p:nvPr/>
+        </p:nvSpPr>
+        <p:spPr>
+          <a:xfrm>
+            <a:off x="530352" y="2788920"/>
+            <a:ext cx="3566160" cy="914400"/>
+          </a:xfrm>
+          <a:prstGeom prst="rect">
+            <a:avLst/>
+          </a:prstGeom>
+          <a:noFill/>
+        </p:spPr>
+        <p:txBody>
+          <a:bodyPr wrap="none" lIns="18288" rIns="18288" anchor="ctr">
+            <a:spAutoFit/>
+          </a:bodyPr>
+          <a:lstStyle/>
+          <a:p>
+            <a:pPr algn="l"/>
+            <a:r>
+              <a:rPr sz="1500" b="0">
+                <a:solidFill>
+                  <a:srgbClr val="35514C"/>
+                </a:solidFill>
+                <a:latin typeface="Georgia"/>
+              </a:rPr>
+              <a:t>The overview turns an ensemble-learning study into a visual reading: one profile, eight signals, and two different ways to combine small decisions.</a:t>
+            </a:r>
+          </a:p>
+        </p:txBody>
+      </p:sp>
+      <p:sp>
+        <p:nvSpPr>
+          <p:cNvPr id="9" name="Rectangle 8"/>
           <p:cNvSpPr/>
           <p:nvPr/>
         </p:nvSpPr>
         <p:spPr>
           <a:xfrm>
-            <a:off x="7772400" y="1280160"/>
-            <a:ext cx="2926080" cy="2926080"/>
-          </a:xfrm>
-          <a:prstGeom prst="ellipse">
+            <a:off x="530352" y="4041648"/>
+            <a:ext cx="3337560" cy="914400"/>
+          </a:xfrm>
+          <a:prstGeom prst="rect">
             <a:avLst/>
           </a:prstGeom>
           <a:solidFill>
-            <a:srgbClr val="198B83"/>
+            <a:srgbClr val="123F3B"/>
           </a:solidFill>
-          <a:ln>
+          <a:ln w="7620">
             <a:solidFill>
-              <a:srgbClr val="198B83"/>
+              <a:srgbClr val="123F3B"/>
             </a:solidFill>
           </a:ln>
         </p:spPr>
@@ -3287,14 +3392,14 @@
       </p:sp>
       <p:sp>
         <p:nvSpPr>
-          <p:cNvPr id="7" name="TextBox 6"/>
+          <p:cNvPr id="10" name="TextBox 9"/>
           <p:cNvSpPr txBox="1"/>
           <p:nvPr/>
         </p:nvSpPr>
         <p:spPr>
           <a:xfrm>
-            <a:off x="8138160" y="2011680"/>
-            <a:ext cx="2194560" cy="548640"/>
+            <a:off x="749808" y="4242816"/>
+            <a:ext cx="2880360" cy="457200"/>
           </a:xfrm>
           <a:prstGeom prst="rect">
             <a:avLst/>
@@ -3307,125 +3412,89 @@
           </a:bodyPr>
           <a:lstStyle/>
           <a:p>
+            <a:pPr algn="l"/>
+            <a:r>
+              <a:rPr sz="1500" b="0">
+                <a:solidFill>
+                  <a:srgbClr val="F7FAF5"/>
+                </a:solidFill>
+                <a:latin typeface="Georgia"/>
+              </a:rPr>
+              <a:t>Both learners read the same record.
+Their learning habits are different.</a:t>
+            </a:r>
+          </a:p>
+        </p:txBody>
+      </p:sp>
+      <p:sp>
+        <p:nvSpPr>
+          <p:cNvPr id="11" name="Rectangle 10"/>
+          <p:cNvSpPr/>
+          <p:nvPr/>
+        </p:nvSpPr>
+        <p:spPr>
+          <a:xfrm>
+            <a:off x="4526280" y="945514"/>
+            <a:ext cx="7178040" cy="5012690"/>
+          </a:xfrm>
+          <a:prstGeom prst="rect">
+            <a:avLst/>
+          </a:prstGeom>
+          <a:solidFill>
+            <a:srgbClr val="F7FAF5"/>
+          </a:solidFill>
+          <a:ln w="7620">
+            <a:solidFill>
+              <a:srgbClr val="B8C5BC"/>
+            </a:solidFill>
+          </a:ln>
+        </p:spPr>
+        <p:style>
+          <a:lnRef idx="1">
+            <a:schemeClr val="accent1"/>
+          </a:lnRef>
+          <a:fillRef idx="3">
+            <a:schemeClr val="accent1"/>
+          </a:fillRef>
+          <a:effectRef idx="2">
+            <a:schemeClr val="accent1"/>
+          </a:effectRef>
+          <a:fontRef idx="minor">
+            <a:schemeClr val="lt1"/>
+          </a:fontRef>
+        </p:style>
+        <p:txBody>
+          <a:bodyPr rtlCol="0" anchor="ctr"/>
+          <a:lstStyle/>
+          <a:p>
             <a:pPr algn="ctr"/>
-            <a:r>
-              <a:rPr sz="2500" b="1">
-                <a:solidFill>
-                  <a:srgbClr val="FFFFFF"/>
-                </a:solidFill>
-                <a:latin typeface="Aptos"/>
-              </a:rPr>
-              <a:t>RF  ×  GB</a:t>
-            </a:r>
-          </a:p>
-        </p:txBody>
-      </p:sp>
-      <p:sp>
-        <p:nvSpPr>
-          <p:cNvPr id="8" name="TextBox 7"/>
-          <p:cNvSpPr txBox="1"/>
+          </a:p>
+        </p:txBody>
+      </p:sp>
+      <p:pic>
+        <p:nvPicPr>
+          <p:cNvPr id="12" name="Picture 11" descr="01-overview.png"/>
+          <p:cNvPicPr>
+            <a:picLocks noChangeAspect="1"/>
+          </p:cNvPicPr>
           <p:nvPr/>
-        </p:nvSpPr>
-        <p:spPr>
-          <a:xfrm>
-            <a:off x="8183879" y="2761488"/>
-            <a:ext cx="2103120" cy="640080"/>
-          </a:xfrm>
-          <a:prstGeom prst="rect">
-            <a:avLst/>
-          </a:prstGeom>
-          <a:noFill/>
-        </p:spPr>
-        <p:txBody>
-          <a:bodyPr wrap="none" lIns="18288" rIns="18288" anchor="ctr">
-            <a:spAutoFit/>
-          </a:bodyPr>
-          <a:lstStyle/>
-          <a:p>
-            <a:pPr algn="ctr"/>
-            <a:r>
-              <a:rPr sz="1100" b="1">
-                <a:solidFill>
-                  <a:srgbClr val="E7F6F3"/>
-                </a:solidFill>
-                <a:latin typeface="Aptos"/>
-              </a:rPr>
-              <a:t>clinical signals
-→ model evidence</a:t>
-            </a:r>
-          </a:p>
-        </p:txBody>
-      </p:sp>
-      <p:sp>
-        <p:nvSpPr>
-          <p:cNvPr id="9" name="TextBox 8"/>
-          <p:cNvSpPr txBox="1"/>
-          <p:nvPr/>
-        </p:nvSpPr>
-        <p:spPr>
-          <a:xfrm>
-            <a:off x="502920" y="6473952"/>
-            <a:ext cx="5029200" cy="228600"/>
-          </a:xfrm>
-          <a:prstGeom prst="rect">
-            <a:avLst/>
-          </a:prstGeom>
-          <a:noFill/>
-        </p:spPr>
-        <p:txBody>
-          <a:bodyPr wrap="none" lIns="18288" rIns="18288" anchor="ctr">
-            <a:spAutoFit/>
-          </a:bodyPr>
-          <a:lstStyle/>
-          <a:p>
-            <a:pPr algn="l"/>
-            <a:r>
-              <a:rPr sz="700" b="1">
-                <a:solidFill>
-                  <a:srgbClr val="6F7E88"/>
-                </a:solidFill>
-                <a:latin typeface="Aptos"/>
-              </a:rPr>
-              <a:t>DIABETES ENSEMBLE LAB  •  MINI-PROJECT</a:t>
-            </a:r>
-          </a:p>
-        </p:txBody>
-      </p:sp>
-      <p:sp>
-        <p:nvSpPr>
-          <p:cNvPr id="10" name="TextBox 9"/>
-          <p:cNvSpPr txBox="1"/>
-          <p:nvPr/>
-        </p:nvSpPr>
-        <p:spPr>
-          <a:xfrm>
-            <a:off x="10881360" y="6473952"/>
-            <a:ext cx="777240" cy="228600"/>
-          </a:xfrm>
-          <a:prstGeom prst="rect">
-            <a:avLst/>
-          </a:prstGeom>
-          <a:noFill/>
-        </p:spPr>
-        <p:txBody>
-          <a:bodyPr wrap="none" lIns="18288" rIns="18288" anchor="ctr">
-            <a:spAutoFit/>
-          </a:bodyPr>
-          <a:lstStyle/>
-          <a:p>
-            <a:pPr algn="r"/>
-            <a:r>
-              <a:rPr sz="700" b="1">
-                <a:solidFill>
-                  <a:srgbClr val="6F7E88"/>
-                </a:solidFill>
-                <a:latin typeface="Aptos"/>
-              </a:rPr>
-              <a:t>01 / 04</a:t>
-            </a:r>
-          </a:p>
-        </p:txBody>
-      </p:sp>
+        </p:nvPicPr>
+        <p:blipFill>
+          <a:blip r:embed="rId2"/>
+          <a:stretch>
+            <a:fillRect/>
+          </a:stretch>
+        </p:blipFill>
+        <p:spPr>
+          <a:xfrm>
+            <a:off x="4572000" y="991234"/>
+            <a:ext cx="7086600" cy="4921250"/>
+          </a:xfrm>
+          <a:prstGeom prst="rect">
+            <a:avLst/>
+          </a:prstGeom>
+        </p:spPr>
+      </p:pic>
     </p:spTree>
   </p:cSld>
   <p:clrMapOvr>
@@ -3440,7 +3509,7 @@
     <p:bg>
       <p:bgPr>
         <a:solidFill>
-          <a:srgbClr val="FFFFFF"/>
+          <a:srgbClr val="E5E8E1"/>
         </a:solidFill>
         <a:effectLst/>
       </p:bgPr>
@@ -3460,8 +3529,8 @@
         </p:nvSpPr>
         <p:spPr>
           <a:xfrm>
-            <a:off x="594360" y="475488"/>
-            <a:ext cx="4114800" cy="228600"/>
+            <a:off x="502920" y="256032"/>
+            <a:ext cx="2926080" cy="182880"/>
           </a:xfrm>
           <a:prstGeom prst="rect">
             <a:avLst/>
@@ -3476,13 +3545,13 @@
           <a:p>
             <a:pPr algn="l"/>
             <a:r>
-              <a:rPr sz="900" b="1">
-                <a:solidFill>
-                  <a:srgbClr val="198B83"/>
+              <a:rPr sz="800" b="1">
+                <a:solidFill>
+                  <a:srgbClr val="05685F"/>
                 </a:solidFill>
                 <a:latin typeface="Aptos"/>
               </a:rPr>
-              <a:t>01  /  DATA + METHOD</a:t>
+              <a:t>DIABETES MODEL STUDY</a:t>
             </a:r>
           </a:p>
         </p:txBody>
@@ -3495,8 +3564,8 @@
         </p:nvSpPr>
         <p:spPr>
           <a:xfrm>
-            <a:off x="594360" y="841248"/>
-            <a:ext cx="8595360" cy="502920"/>
+            <a:off x="8229600" y="256032"/>
+            <a:ext cx="3200400" cy="182880"/>
           </a:xfrm>
           <a:prstGeom prst="rect">
             <a:avLst/>
@@ -3509,39 +3578,390 @@
           </a:bodyPr>
           <a:lstStyle/>
           <a:p>
-            <a:pPr algn="l"/>
-            <a:r>
-              <a:rPr sz="2400" b="1">
-                <a:solidFill>
-                  <a:srgbClr val="172D3A"/>
+            <a:pPr algn="r"/>
+            <a:r>
+              <a:rPr sz="800" b="0">
+                <a:solidFill>
+                  <a:srgbClr val="35514C"/>
                 </a:solidFill>
                 <a:latin typeface="Aptos"/>
               </a:rPr>
-              <a:t>From patient signals to tuned ensembles.</a:t>
-            </a:r>
-          </a:p>
-        </p:txBody>
-      </p:sp>
-      <p:sp>
-        <p:nvSpPr>
-          <p:cNvPr id="4" name="Rounded Rectangle 3"/>
+              <a:t>Prediction</a:t>
+            </a:r>
+          </a:p>
+        </p:txBody>
+      </p:sp>
+      <p:sp>
+        <p:nvSpPr>
+          <p:cNvPr id="4" name="TextBox 3"/>
+          <p:cNvSpPr txBox="1"/>
+          <p:nvPr/>
+        </p:nvSpPr>
+        <p:spPr>
+          <a:xfrm>
+            <a:off x="10972800" y="6519672"/>
+            <a:ext cx="685800" cy="164592"/>
+          </a:xfrm>
+          <a:prstGeom prst="rect">
+            <a:avLst/>
+          </a:prstGeom>
+          <a:noFill/>
+        </p:spPr>
+        <p:txBody>
+          <a:bodyPr wrap="none" lIns="18288" rIns="18288" anchor="ctr">
+            <a:spAutoFit/>
+          </a:bodyPr>
+          <a:lstStyle/>
+          <a:p>
+            <a:pPr algn="r"/>
+            <a:r>
+              <a:rPr sz="800" b="1">
+                <a:solidFill>
+                  <a:srgbClr val="35514C"/>
+                </a:solidFill>
+                <a:latin typeface="Aptos"/>
+              </a:rPr>
+              <a:t>02 / 04</a:t>
+            </a:r>
+          </a:p>
+        </p:txBody>
+      </p:sp>
+      <p:sp>
+        <p:nvSpPr>
+          <p:cNvPr id="5" name="TextBox 4"/>
+          <p:cNvSpPr txBox="1"/>
+          <p:nvPr/>
+        </p:nvSpPr>
+        <p:spPr>
+          <a:xfrm>
+            <a:off x="502920" y="6519672"/>
+            <a:ext cx="4114800" cy="164592"/>
+          </a:xfrm>
+          <a:prstGeom prst="rect">
+            <a:avLst/>
+          </a:prstGeom>
+          <a:noFill/>
+        </p:spPr>
+        <p:txBody>
+          <a:bodyPr wrap="none" lIns="18288" rIns="18288" anchor="ctr">
+            <a:spAutoFit/>
+          </a:bodyPr>
+          <a:lstStyle/>
+          <a:p>
+            <a:pPr algn="l"/>
+            <a:r>
+              <a:rPr sz="800" b="0">
+                <a:solidFill>
+                  <a:srgbClr val="35514C"/>
+                </a:solidFill>
+                <a:latin typeface="Aptos"/>
+              </a:rPr>
+              <a:t>Working Next.js prototype · educational use only</a:t>
+            </a:r>
+          </a:p>
+        </p:txBody>
+      </p:sp>
+      <p:sp>
+        <p:nvSpPr>
+          <p:cNvPr id="6" name="TextBox 5"/>
+          <p:cNvSpPr txBox="1"/>
+          <p:nvPr/>
+        </p:nvSpPr>
+        <p:spPr>
+          <a:xfrm>
+            <a:off x="502920" y="960120"/>
+            <a:ext cx="3749039" cy="1097280"/>
+          </a:xfrm>
+          <a:prstGeom prst="rect">
+            <a:avLst/>
+          </a:prstGeom>
+          <a:noFill/>
+        </p:spPr>
+        <p:txBody>
+          <a:bodyPr wrap="none" lIns="18288" rIns="18288" anchor="ctr">
+            <a:spAutoFit/>
+          </a:bodyPr>
+          <a:lstStyle/>
+          <a:p>
+            <a:pPr algn="l"/>
+            <a:r>
+              <a:rPr sz="3000" b="0">
+                <a:solidFill>
+                  <a:srgbClr val="172F2D"/>
+                </a:solidFill>
+                <a:latin typeface="Georgia"/>
+              </a:rPr>
+              <a:t>One profile,
+two estimates.</a:t>
+            </a:r>
+          </a:p>
+        </p:txBody>
+      </p:sp>
+      <p:sp>
+        <p:nvSpPr>
+          <p:cNvPr id="7" name="TextBox 6"/>
+          <p:cNvSpPr txBox="1"/>
+          <p:nvPr/>
+        </p:nvSpPr>
+        <p:spPr>
+          <a:xfrm>
+            <a:off x="530352" y="2395728"/>
+            <a:ext cx="3383280" cy="292608"/>
+          </a:xfrm>
+          <a:prstGeom prst="rect">
+            <a:avLst/>
+          </a:prstGeom>
+          <a:noFill/>
+        </p:spPr>
+        <p:txBody>
+          <a:bodyPr wrap="none" lIns="18288" rIns="18288" anchor="ctr">
+            <a:spAutoFit/>
+          </a:bodyPr>
+          <a:lstStyle/>
+          <a:p>
+            <a:pPr algn="l"/>
+            <a:r>
+              <a:rPr sz="1600" b="1">
+                <a:solidFill>
+                  <a:srgbClr val="05685F"/>
+                </a:solidFill>
+                <a:latin typeface="Aptos"/>
+              </a:rPr>
+              <a:t>The working flow</a:t>
+            </a:r>
+          </a:p>
+        </p:txBody>
+      </p:sp>
+      <p:sp>
+        <p:nvSpPr>
+          <p:cNvPr id="8" name="TextBox 7"/>
+          <p:cNvSpPr txBox="1"/>
+          <p:nvPr/>
+        </p:nvSpPr>
+        <p:spPr>
+          <a:xfrm>
+            <a:off x="530352" y="2834640"/>
+            <a:ext cx="164592" cy="219456"/>
+          </a:xfrm>
+          <a:prstGeom prst="rect">
+            <a:avLst/>
+          </a:prstGeom>
+          <a:noFill/>
+        </p:spPr>
+        <p:txBody>
+          <a:bodyPr wrap="none" lIns="18288" rIns="18288" anchor="ctr">
+            <a:spAutoFit/>
+          </a:bodyPr>
+          <a:lstStyle/>
+          <a:p>
+            <a:pPr algn="l"/>
+            <a:r>
+              <a:rPr sz="1600" b="1">
+                <a:solidFill>
+                  <a:srgbClr val="A8443F"/>
+                </a:solidFill>
+                <a:latin typeface="Aptos"/>
+              </a:rPr>
+              <a:t>•</a:t>
+            </a:r>
+          </a:p>
+        </p:txBody>
+      </p:sp>
+      <p:sp>
+        <p:nvSpPr>
+          <p:cNvPr id="9" name="TextBox 8"/>
+          <p:cNvSpPr txBox="1"/>
+          <p:nvPr/>
+        </p:nvSpPr>
+        <p:spPr>
+          <a:xfrm>
+            <a:off x="786384" y="2825496"/>
+            <a:ext cx="3264408" cy="457200"/>
+          </a:xfrm>
+          <a:prstGeom prst="rect">
+            <a:avLst/>
+          </a:prstGeom>
+          <a:noFill/>
+        </p:spPr>
+        <p:txBody>
+          <a:bodyPr wrap="none" lIns="18288" rIns="18288" anchor="ctr">
+            <a:spAutoFit/>
+          </a:bodyPr>
+          <a:lstStyle/>
+          <a:p>
+            <a:pPr algn="l"/>
+            <a:r>
+              <a:rPr sz="1300" b="0">
+                <a:solidFill>
+                  <a:srgbClr val="172F2D"/>
+                </a:solidFill>
+                <a:latin typeface="Aptos"/>
+              </a:rPr>
+              <a:t>Enter eight fields from the dataset.</a:t>
+            </a:r>
+          </a:p>
+        </p:txBody>
+      </p:sp>
+      <p:sp>
+        <p:nvSpPr>
+          <p:cNvPr id="10" name="TextBox 9"/>
+          <p:cNvSpPr txBox="1"/>
+          <p:nvPr/>
+        </p:nvSpPr>
+        <p:spPr>
+          <a:xfrm>
+            <a:off x="530352" y="3493008"/>
+            <a:ext cx="164592" cy="219456"/>
+          </a:xfrm>
+          <a:prstGeom prst="rect">
+            <a:avLst/>
+          </a:prstGeom>
+          <a:noFill/>
+        </p:spPr>
+        <p:txBody>
+          <a:bodyPr wrap="none" lIns="18288" rIns="18288" anchor="ctr">
+            <a:spAutoFit/>
+          </a:bodyPr>
+          <a:lstStyle/>
+          <a:p>
+            <a:pPr algn="l"/>
+            <a:r>
+              <a:rPr sz="1600" b="1">
+                <a:solidFill>
+                  <a:srgbClr val="A8443F"/>
+                </a:solidFill>
+                <a:latin typeface="Aptos"/>
+              </a:rPr>
+              <a:t>•</a:t>
+            </a:r>
+          </a:p>
+        </p:txBody>
+      </p:sp>
+      <p:sp>
+        <p:nvSpPr>
+          <p:cNvPr id="11" name="TextBox 10"/>
+          <p:cNvSpPr txBox="1"/>
+          <p:nvPr/>
+        </p:nvSpPr>
+        <p:spPr>
+          <a:xfrm>
+            <a:off x="786384" y="3483864"/>
+            <a:ext cx="3264408" cy="457200"/>
+          </a:xfrm>
+          <a:prstGeom prst="rect">
+            <a:avLst/>
+          </a:prstGeom>
+          <a:noFill/>
+        </p:spPr>
+        <p:txBody>
+          <a:bodyPr wrap="none" lIns="18288" rIns="18288" anchor="ctr">
+            <a:spAutoFit/>
+          </a:bodyPr>
+          <a:lstStyle/>
+          <a:p>
+            <a:pPr algn="l"/>
+            <a:r>
+              <a:rPr sz="1300" b="0">
+                <a:solidFill>
+                  <a:srgbClr val="172F2D"/>
+                </a:solidFill>
+                <a:latin typeface="Aptos"/>
+              </a:rPr>
+              <a:t>Send the same profile to both trained models.</a:t>
+            </a:r>
+          </a:p>
+        </p:txBody>
+      </p:sp>
+      <p:sp>
+        <p:nvSpPr>
+          <p:cNvPr id="12" name="TextBox 11"/>
+          <p:cNvSpPr txBox="1"/>
+          <p:nvPr/>
+        </p:nvSpPr>
+        <p:spPr>
+          <a:xfrm>
+            <a:off x="530352" y="4151376"/>
+            <a:ext cx="164592" cy="219456"/>
+          </a:xfrm>
+          <a:prstGeom prst="rect">
+            <a:avLst/>
+          </a:prstGeom>
+          <a:noFill/>
+        </p:spPr>
+        <p:txBody>
+          <a:bodyPr wrap="none" lIns="18288" rIns="18288" anchor="ctr">
+            <a:spAutoFit/>
+          </a:bodyPr>
+          <a:lstStyle/>
+          <a:p>
+            <a:pPr algn="l"/>
+            <a:r>
+              <a:rPr sz="1600" b="1">
+                <a:solidFill>
+                  <a:srgbClr val="A8443F"/>
+                </a:solidFill>
+                <a:latin typeface="Aptos"/>
+              </a:rPr>
+              <a:t>•</a:t>
+            </a:r>
+          </a:p>
+        </p:txBody>
+      </p:sp>
+      <p:sp>
+        <p:nvSpPr>
+          <p:cNvPr id="13" name="TextBox 12"/>
+          <p:cNvSpPr txBox="1"/>
+          <p:nvPr/>
+        </p:nvSpPr>
+        <p:spPr>
+          <a:xfrm>
+            <a:off x="786384" y="4142232"/>
+            <a:ext cx="3264408" cy="457200"/>
+          </a:xfrm>
+          <a:prstGeom prst="rect">
+            <a:avLst/>
+          </a:prstGeom>
+          <a:noFill/>
+        </p:spPr>
+        <p:txBody>
+          <a:bodyPr wrap="none" lIns="18288" rIns="18288" anchor="ctr">
+            <a:spAutoFit/>
+          </a:bodyPr>
+          <a:lstStyle/>
+          <a:p>
+            <a:pPr algn="l"/>
+            <a:r>
+              <a:rPr sz="1300" b="0">
+                <a:solidFill>
+                  <a:srgbClr val="172F2D"/>
+                </a:solidFill>
+                <a:latin typeface="Aptos"/>
+              </a:rPr>
+              <a:t>Read lower or higher likelihood in plain language.</a:t>
+            </a:r>
+          </a:p>
+        </p:txBody>
+      </p:sp>
+      <p:sp>
+        <p:nvSpPr>
+          <p:cNvPr id="14" name="Rectangle 13"/>
           <p:cNvSpPr/>
           <p:nvPr/>
         </p:nvSpPr>
         <p:spPr>
           <a:xfrm>
-            <a:off x="640080" y="1691640"/>
-            <a:ext cx="3337560" cy="1170432"/>
-          </a:xfrm>
-          <a:prstGeom prst="roundRect">
+            <a:off x="530352" y="5047488"/>
+            <a:ext cx="3337560" cy="658368"/>
+          </a:xfrm>
+          <a:prstGeom prst="rect">
             <a:avLst/>
           </a:prstGeom>
           <a:solidFill>
-            <a:srgbClr val="E7F6F3"/>
+            <a:srgbClr val="E5CC70"/>
           </a:solidFill>
-          <a:ln w="8890">
+          <a:ln w="7620">
             <a:solidFill>
-              <a:srgbClr val="E7F6F3"/>
+              <a:srgbClr val="E5CC70"/>
             </a:solidFill>
           </a:ln>
         </p:spPr>
@@ -3569,14 +3989,14 @@
       </p:sp>
       <p:sp>
         <p:nvSpPr>
-          <p:cNvPr id="5" name="TextBox 4"/>
+          <p:cNvPr id="15" name="TextBox 14"/>
           <p:cNvSpPr txBox="1"/>
           <p:nvPr/>
         </p:nvSpPr>
         <p:spPr>
           <a:xfrm>
-            <a:off x="822959" y="1865376"/>
-            <a:ext cx="594360" cy="347472"/>
+            <a:off x="731520" y="5202936"/>
+            <a:ext cx="2907792" cy="329184"/>
           </a:xfrm>
           <a:prstGeom prst="rect">
             <a:avLst/>
@@ -3591,108 +4011,37 @@
           <a:p>
             <a:pPr algn="l"/>
             <a:r>
-              <a:rPr sz="2100" b="1">
-                <a:solidFill>
-                  <a:srgbClr val="198B83"/>
-                </a:solidFill>
-                <a:latin typeface="Aptos"/>
+              <a:rPr sz="1200" b="0">
+                <a:solidFill>
+                  <a:srgbClr val="172F2D"/>
+                </a:solidFill>
+                <a:latin typeface="Georgia"/>
               </a:rPr>
-              <a:t>08</a:t>
-            </a:r>
-          </a:p>
-        </p:txBody>
-      </p:sp>
-      <p:sp>
-        <p:nvSpPr>
-          <p:cNvPr id="6" name="TextBox 5"/>
-          <p:cNvSpPr txBox="1"/>
-          <p:nvPr/>
-        </p:nvSpPr>
-        <p:spPr>
-          <a:xfrm>
-            <a:off x="1554480" y="1856231"/>
-            <a:ext cx="2103120" cy="228600"/>
-          </a:xfrm>
-          <a:prstGeom prst="rect">
-            <a:avLst/>
-          </a:prstGeom>
-          <a:noFill/>
-        </p:spPr>
-        <p:txBody>
-          <a:bodyPr wrap="none" lIns="18288" rIns="18288" anchor="ctr">
-            <a:spAutoFit/>
-          </a:bodyPr>
-          <a:lstStyle/>
-          <a:p>
-            <a:pPr algn="l"/>
-            <a:r>
-              <a:rPr sz="800" b="1">
-                <a:solidFill>
-                  <a:srgbClr val="198B83"/>
-                </a:solidFill>
-                <a:latin typeface="Aptos"/>
-              </a:rPr>
-              <a:t>INPUT FEATURES</a:t>
-            </a:r>
-          </a:p>
-        </p:txBody>
-      </p:sp>
-      <p:sp>
-        <p:nvSpPr>
-          <p:cNvPr id="7" name="TextBox 6"/>
-          <p:cNvSpPr txBox="1"/>
-          <p:nvPr/>
-        </p:nvSpPr>
-        <p:spPr>
-          <a:xfrm>
-            <a:off x="1554480" y="2103120"/>
-            <a:ext cx="2194560" cy="457200"/>
-          </a:xfrm>
-          <a:prstGeom prst="rect">
-            <a:avLst/>
-          </a:prstGeom>
-          <a:noFill/>
-        </p:spPr>
-        <p:txBody>
-          <a:bodyPr wrap="none" lIns="18288" rIns="18288" anchor="ctr">
-            <a:spAutoFit/>
-          </a:bodyPr>
-          <a:lstStyle/>
-          <a:p>
-            <a:pPr algn="l"/>
-            <a:r>
-              <a:rPr sz="1000" b="0">
-                <a:solidFill>
-                  <a:srgbClr val="2C3D48"/>
-                </a:solidFill>
-                <a:latin typeface="Aptos"/>
-              </a:rPr>
-              <a:t>Age, BMI, HbA1c, glucose,
-conditions, and categories.</a:t>
-            </a:r>
-          </a:p>
-        </p:txBody>
-      </p:sp>
-      <p:sp>
-        <p:nvSpPr>
-          <p:cNvPr id="8" name="Rounded Rectangle 7"/>
+              <a:t>The percentage is a model output — not a diagnosis or a personal medical risk score.</a:t>
+            </a:r>
+          </a:p>
+        </p:txBody>
+      </p:sp>
+      <p:sp>
+        <p:nvSpPr>
+          <p:cNvPr id="16" name="Rectangle 15"/>
           <p:cNvSpPr/>
           <p:nvPr/>
         </p:nvSpPr>
         <p:spPr>
           <a:xfrm>
-            <a:off x="4407408" y="1691640"/>
-            <a:ext cx="3337560" cy="1170432"/>
-          </a:xfrm>
-          <a:prstGeom prst="roundRect">
+            <a:off x="4526280" y="945514"/>
+            <a:ext cx="7178040" cy="5012690"/>
+          </a:xfrm>
+          <a:prstGeom prst="rect">
             <a:avLst/>
           </a:prstGeom>
           <a:solidFill>
-            <a:srgbClr val="E7F6F3"/>
+            <a:srgbClr val="F7FAF5"/>
           </a:solidFill>
-          <a:ln w="8890">
+          <a:ln w="7620">
             <a:solidFill>
-              <a:srgbClr val="E7F6F3"/>
+              <a:srgbClr val="B8C5BC"/>
             </a:solidFill>
           </a:ln>
         </p:spPr>
@@ -3718,16 +4067,66 @@
           </a:p>
         </p:txBody>
       </p:sp>
-      <p:sp>
-        <p:nvSpPr>
-          <p:cNvPr id="9" name="TextBox 8"/>
+      <p:pic>
+        <p:nvPicPr>
+          <p:cNvPr id="17" name="Picture 16" descr="02-predict-result.png"/>
+          <p:cNvPicPr>
+            <a:picLocks noChangeAspect="1"/>
+          </p:cNvPicPr>
+          <p:nvPr/>
+        </p:nvPicPr>
+        <p:blipFill>
+          <a:blip r:embed="rId2"/>
+          <a:stretch>
+            <a:fillRect/>
+          </a:stretch>
+        </p:blipFill>
+        <p:spPr>
+          <a:xfrm>
+            <a:off x="4572000" y="991234"/>
+            <a:ext cx="7086600" cy="4921250"/>
+          </a:xfrm>
+          <a:prstGeom prst="rect">
+            <a:avLst/>
+          </a:prstGeom>
+        </p:spPr>
+      </p:pic>
+    </p:spTree>
+  </p:cSld>
+  <p:clrMapOvr>
+    <a:masterClrMapping/>
+  </p:clrMapOvr>
+</p:sld>
+</file>
+
+<file path=ppt/slides/slide3.xml><?xml version="1.0" encoding="utf-8"?>
+<p:sld xmlns:a="http://schemas.openxmlformats.org/drawingml/2006/main" xmlns:p="http://schemas.openxmlformats.org/presentationml/2006/main" xmlns:r="http://schemas.openxmlformats.org/officeDocument/2006/relationships">
+  <p:cSld>
+    <p:bg>
+      <p:bgPr>
+        <a:solidFill>
+          <a:srgbClr val="E5E8E1"/>
+        </a:solidFill>
+        <a:effectLst/>
+      </p:bgPr>
+    </p:bg>
+    <p:spTree>
+      <p:nvGrpSpPr>
+        <p:cNvPr id="1" name=""/>
+        <p:cNvGrpSpPr/>
+        <p:nvPr/>
+      </p:nvGrpSpPr>
+      <p:grpSpPr/>
+      <p:sp>
+        <p:nvSpPr>
+          <p:cNvPr id="2" name="TextBox 1"/>
           <p:cNvSpPr txBox="1"/>
           <p:nvPr/>
         </p:nvSpPr>
         <p:spPr>
           <a:xfrm>
-            <a:off x="4590288" y="1865376"/>
-            <a:ext cx="594360" cy="347472"/>
+            <a:off x="502920" y="256032"/>
+            <a:ext cx="2926080" cy="182880"/>
           </a:xfrm>
           <a:prstGeom prst="rect">
             <a:avLst/>
@@ -3742,27 +4141,27 @@
           <a:p>
             <a:pPr algn="l"/>
             <a:r>
-              <a:rPr sz="2100" b="1">
-                <a:solidFill>
-                  <a:srgbClr val="198B83"/>
+              <a:rPr sz="800" b="1">
+                <a:solidFill>
+                  <a:srgbClr val="05685F"/>
                 </a:solidFill>
                 <a:latin typeface="Aptos"/>
               </a:rPr>
-              <a:t>01</a:t>
-            </a:r>
-          </a:p>
-        </p:txBody>
-      </p:sp>
-      <p:sp>
-        <p:nvSpPr>
-          <p:cNvPr id="10" name="TextBox 9"/>
+              <a:t>DIABETES MODEL STUDY</a:t>
+            </a:r>
+          </a:p>
+        </p:txBody>
+      </p:sp>
+      <p:sp>
+        <p:nvSpPr>
+          <p:cNvPr id="3" name="TextBox 2"/>
           <p:cNvSpPr txBox="1"/>
           <p:nvPr/>
         </p:nvSpPr>
         <p:spPr>
           <a:xfrm>
-            <a:off x="5321808" y="1856231"/>
-            <a:ext cx="2103120" cy="228600"/>
+            <a:off x="8229600" y="256032"/>
+            <a:ext cx="3200400" cy="182880"/>
           </a:xfrm>
           <a:prstGeom prst="rect">
             <a:avLst/>
@@ -3775,29 +4174,29 @@
           </a:bodyPr>
           <a:lstStyle/>
           <a:p>
-            <a:pPr algn="l"/>
-            <a:r>
-              <a:rPr sz="800" b="1">
-                <a:solidFill>
-                  <a:srgbClr val="198B83"/>
+            <a:pPr algn="r"/>
+            <a:r>
+              <a:rPr sz="800" b="0">
+                <a:solidFill>
+                  <a:srgbClr val="35514C"/>
                 </a:solidFill>
                 <a:latin typeface="Aptos"/>
               </a:rPr>
-              <a:t>BINARY TARGET</a:t>
-            </a:r>
-          </a:p>
-        </p:txBody>
-      </p:sp>
-      <p:sp>
-        <p:nvSpPr>
-          <p:cNvPr id="11" name="TextBox 10"/>
+              <a:t>Compare models</a:t>
+            </a:r>
+          </a:p>
+        </p:txBody>
+      </p:sp>
+      <p:sp>
+        <p:nvSpPr>
+          <p:cNvPr id="4" name="TextBox 3"/>
           <p:cNvSpPr txBox="1"/>
           <p:nvPr/>
         </p:nvSpPr>
         <p:spPr>
           <a:xfrm>
-            <a:off x="5321808" y="2103120"/>
-            <a:ext cx="2194560" cy="457200"/>
+            <a:off x="10972800" y="6519672"/>
+            <a:ext cx="685800" cy="164592"/>
           </a:xfrm>
           <a:prstGeom prst="rect">
             <a:avLst/>
@@ -3810,39 +4209,180 @@
           </a:bodyPr>
           <a:lstStyle/>
           <a:p>
-            <a:pPr algn="l"/>
-            <a:r>
-              <a:rPr sz="1000" b="0">
-                <a:solidFill>
-                  <a:srgbClr val="2C3D48"/>
+            <a:pPr algn="r"/>
+            <a:r>
+              <a:rPr sz="800" b="1">
+                <a:solidFill>
+                  <a:srgbClr val="35514C"/>
                 </a:solidFill>
                 <a:latin typeface="Aptos"/>
               </a:rPr>
-              <a:t>diabetes = 0 or 1</a:t>
-            </a:r>
-          </a:p>
-        </p:txBody>
-      </p:sp>
-      <p:sp>
-        <p:nvSpPr>
-          <p:cNvPr id="12" name="Rounded Rectangle 11"/>
+              <a:t>03 / 04</a:t>
+            </a:r>
+          </a:p>
+        </p:txBody>
+      </p:sp>
+      <p:sp>
+        <p:nvSpPr>
+          <p:cNvPr id="5" name="TextBox 4"/>
+          <p:cNvSpPr txBox="1"/>
+          <p:nvPr/>
+        </p:nvSpPr>
+        <p:spPr>
+          <a:xfrm>
+            <a:off x="502920" y="6519672"/>
+            <a:ext cx="4114800" cy="164592"/>
+          </a:xfrm>
+          <a:prstGeom prst="rect">
+            <a:avLst/>
+          </a:prstGeom>
+          <a:noFill/>
+        </p:spPr>
+        <p:txBody>
+          <a:bodyPr wrap="none" lIns="18288" rIns="18288" anchor="ctr">
+            <a:spAutoFit/>
+          </a:bodyPr>
+          <a:lstStyle/>
+          <a:p>
+            <a:pPr algn="l"/>
+            <a:r>
+              <a:rPr sz="800" b="0">
+                <a:solidFill>
+                  <a:srgbClr val="35514C"/>
+                </a:solidFill>
+                <a:latin typeface="Aptos"/>
+              </a:rPr>
+              <a:t>Working Next.js prototype · educational use only</a:t>
+            </a:r>
+          </a:p>
+        </p:txBody>
+      </p:sp>
+      <p:sp>
+        <p:nvSpPr>
+          <p:cNvPr id="6" name="TextBox 5"/>
+          <p:cNvSpPr txBox="1"/>
+          <p:nvPr/>
+        </p:nvSpPr>
+        <p:spPr>
+          <a:xfrm>
+            <a:off x="502920" y="960120"/>
+            <a:ext cx="3749039" cy="1097280"/>
+          </a:xfrm>
+          <a:prstGeom prst="rect">
+            <a:avLst/>
+          </a:prstGeom>
+          <a:noFill/>
+        </p:spPr>
+        <p:txBody>
+          <a:bodyPr wrap="none" lIns="18288" rIns="18288" anchor="ctr">
+            <a:spAutoFit/>
+          </a:bodyPr>
+          <a:lstStyle/>
+          <a:p>
+            <a:pPr algn="l"/>
+            <a:r>
+              <a:rPr sz="3000" b="0">
+                <a:solidFill>
+                  <a:srgbClr val="172F2D"/>
+                </a:solidFill>
+                <a:latin typeface="Georgia"/>
+              </a:rPr>
+              <a:t>A score answers
+a question.</a:t>
+            </a:r>
+          </a:p>
+        </p:txBody>
+      </p:sp>
+      <p:sp>
+        <p:nvSpPr>
+          <p:cNvPr id="7" name="TextBox 6"/>
+          <p:cNvSpPr txBox="1"/>
+          <p:nvPr/>
+        </p:nvSpPr>
+        <p:spPr>
+          <a:xfrm>
+            <a:off x="530352" y="2395728"/>
+            <a:ext cx="3474720" cy="292608"/>
+          </a:xfrm>
+          <a:prstGeom prst="rect">
+            <a:avLst/>
+          </a:prstGeom>
+          <a:noFill/>
+        </p:spPr>
+        <p:txBody>
+          <a:bodyPr wrap="none" lIns="18288" rIns="18288" anchor="ctr">
+            <a:spAutoFit/>
+          </a:bodyPr>
+          <a:lstStyle/>
+          <a:p>
+            <a:pPr algn="l"/>
+            <a:r>
+              <a:rPr sz="1600" b="1">
+                <a:solidFill>
+                  <a:srgbClr val="05685F"/>
+                </a:solidFill>
+                <a:latin typeface="Aptos"/>
+              </a:rPr>
+              <a:t>Why the table matters</a:t>
+            </a:r>
+          </a:p>
+        </p:txBody>
+      </p:sp>
+      <p:sp>
+        <p:nvSpPr>
+          <p:cNvPr id="8" name="TextBox 7"/>
+          <p:cNvSpPr txBox="1"/>
+          <p:nvPr/>
+        </p:nvSpPr>
+        <p:spPr>
+          <a:xfrm>
+            <a:off x="530352" y="2852928"/>
+            <a:ext cx="3611880" cy="1097280"/>
+          </a:xfrm>
+          <a:prstGeom prst="rect">
+            <a:avLst/>
+          </a:prstGeom>
+          <a:noFill/>
+        </p:spPr>
+        <p:txBody>
+          <a:bodyPr wrap="none" lIns="18288" rIns="18288" anchor="ctr">
+            <a:spAutoFit/>
+          </a:bodyPr>
+          <a:lstStyle/>
+          <a:p>
+            <a:pPr algn="l"/>
+            <a:r>
+              <a:rPr sz="1400" b="0">
+                <a:solidFill>
+                  <a:srgbClr val="35514C"/>
+                </a:solidFill>
+                <a:latin typeface="Georgia"/>
+              </a:rPr>
+              <a:t>Accuracy asks how often the whole prediction was correct. Precision asks how often a positive flag was right. Recall asks how many recorded positive cases were found.</a:t>
+            </a:r>
+          </a:p>
+        </p:txBody>
+      </p:sp>
+      <p:sp>
+        <p:nvSpPr>
+          <p:cNvPr id="9" name="Rectangle 8"/>
           <p:cNvSpPr/>
           <p:nvPr/>
         </p:nvSpPr>
         <p:spPr>
           <a:xfrm>
-            <a:off x="8174736" y="1691640"/>
-            <a:ext cx="3337560" cy="1170432"/>
-          </a:xfrm>
-          <a:prstGeom prst="roundRect">
+            <a:off x="530352" y="4343400"/>
+            <a:ext cx="3337560" cy="987552"/>
+          </a:xfrm>
+          <a:prstGeom prst="rect">
             <a:avLst/>
           </a:prstGeom>
           <a:solidFill>
-            <a:srgbClr val="E7F6F3"/>
+            <a:srgbClr val="F7FAF5"/>
           </a:solidFill>
-          <a:ln w="8890">
+          <a:ln w="7620">
             <a:solidFill>
-              <a:srgbClr val="E7F6F3"/>
+              <a:srgbClr val="F7FAF5"/>
             </a:solidFill>
           </a:ln>
         </p:spPr>
@@ -3870,14 +4410,14 @@
       </p:sp>
       <p:sp>
         <p:nvSpPr>
-          <p:cNvPr id="13" name="TextBox 12"/>
+          <p:cNvPr id="10" name="TextBox 9"/>
           <p:cNvSpPr txBox="1"/>
           <p:nvPr/>
         </p:nvSpPr>
         <p:spPr>
           <a:xfrm>
-            <a:off x="8357615" y="1865376"/>
-            <a:ext cx="594360" cy="347472"/>
+            <a:off x="749808" y="4535424"/>
+            <a:ext cx="2852928" cy="594360"/>
           </a:xfrm>
           <a:prstGeom prst="rect">
             <a:avLst/>
@@ -3892,808 +4432,37 @@
           <a:p>
             <a:pPr algn="l"/>
             <a:r>
-              <a:rPr sz="2100" b="1">
-                <a:solidFill>
-                  <a:srgbClr val="198B83"/>
-                </a:solidFill>
-                <a:latin typeface="Aptos"/>
+              <a:rPr sz="1300" b="0">
+                <a:solidFill>
+                  <a:srgbClr val="172F2D"/>
+                </a:solidFill>
+                <a:latin typeface="Georgia"/>
               </a:rPr>
-              <a:t>CV</a:t>
-            </a:r>
-          </a:p>
-        </p:txBody>
-      </p:sp>
-      <p:sp>
-        <p:nvSpPr>
-          <p:cNvPr id="14" name="TextBox 13"/>
-          <p:cNvSpPr txBox="1"/>
-          <p:nvPr/>
-        </p:nvSpPr>
-        <p:spPr>
-          <a:xfrm>
-            <a:off x="9089136" y="1856231"/>
-            <a:ext cx="2103120" cy="228600"/>
-          </a:xfrm>
-          <a:prstGeom prst="rect">
-            <a:avLst/>
-          </a:prstGeom>
-          <a:noFill/>
-        </p:spPr>
-        <p:txBody>
-          <a:bodyPr wrap="none" lIns="18288" rIns="18288" anchor="ctr">
-            <a:spAutoFit/>
-          </a:bodyPr>
-          <a:lstStyle/>
-          <a:p>
-            <a:pPr algn="l"/>
-            <a:r>
-              <a:rPr sz="800" b="1">
-                <a:solidFill>
-                  <a:srgbClr val="198B83"/>
-                </a:solidFill>
-                <a:latin typeface="Aptos"/>
-              </a:rPr>
-              <a:t>RANDOMIZED TUNING</a:t>
-            </a:r>
-          </a:p>
-        </p:txBody>
-      </p:sp>
-      <p:sp>
-        <p:nvSpPr>
-          <p:cNvPr id="15" name="TextBox 14"/>
-          <p:cNvSpPr txBox="1"/>
-          <p:nvPr/>
-        </p:nvSpPr>
-        <p:spPr>
-          <a:xfrm>
-            <a:off x="9089136" y="2103120"/>
-            <a:ext cx="2194560" cy="457200"/>
-          </a:xfrm>
-          <a:prstGeom prst="rect">
-            <a:avLst/>
-          </a:prstGeom>
-          <a:noFill/>
-        </p:spPr>
-        <p:txBody>
-          <a:bodyPr wrap="none" lIns="18288" rIns="18288" anchor="ctr">
-            <a:spAutoFit/>
-          </a:bodyPr>
-          <a:lstStyle/>
-          <a:p>
-            <a:pPr algn="l"/>
-            <a:r>
-              <a:rPr sz="1000" b="0">
-                <a:solidFill>
-                  <a:srgbClr val="2C3D48"/>
-                </a:solidFill>
-                <a:latin typeface="Aptos"/>
-              </a:rPr>
-              <a:t>Stratified search keeps
-class balance visible.</a:t>
-            </a:r>
-          </a:p>
-        </p:txBody>
-      </p:sp>
-      <p:sp>
-        <p:nvSpPr>
-          <p:cNvPr id="16" name="TextBox 15"/>
-          <p:cNvSpPr txBox="1"/>
-          <p:nvPr/>
-        </p:nvSpPr>
-        <p:spPr>
-          <a:xfrm>
-            <a:off x="658368" y="3401568"/>
-            <a:ext cx="2926080" cy="228600"/>
-          </a:xfrm>
-          <a:prstGeom prst="rect">
-            <a:avLst/>
-          </a:prstGeom>
-          <a:noFill/>
-        </p:spPr>
-        <p:txBody>
-          <a:bodyPr wrap="none" lIns="18288" rIns="18288" anchor="ctr">
-            <a:spAutoFit/>
-          </a:bodyPr>
-          <a:lstStyle/>
-          <a:p>
-            <a:pPr algn="l"/>
-            <a:r>
-              <a:rPr sz="900" b="1">
-                <a:solidFill>
-                  <a:srgbClr val="6F7E88"/>
-                </a:solidFill>
-                <a:latin typeface="Aptos"/>
-              </a:rPr>
-              <a:t>PREPROCESSING PIPELINE</a:t>
-            </a:r>
-          </a:p>
-        </p:txBody>
-      </p:sp>
-      <p:sp>
-        <p:nvSpPr>
-          <p:cNvPr id="17" name="TextBox 16"/>
-          <p:cNvSpPr txBox="1"/>
-          <p:nvPr/>
-        </p:nvSpPr>
-        <p:spPr>
-          <a:xfrm>
-            <a:off x="658368" y="3813048"/>
-            <a:ext cx="320040" cy="219456"/>
-          </a:xfrm>
-          <a:prstGeom prst="rect">
-            <a:avLst/>
-          </a:prstGeom>
-          <a:noFill/>
-        </p:spPr>
-        <p:txBody>
-          <a:bodyPr wrap="none" lIns="18288" rIns="18288" anchor="ctr">
-            <a:spAutoFit/>
-          </a:bodyPr>
-          <a:lstStyle/>
-          <a:p>
-            <a:pPr algn="l"/>
-            <a:r>
-              <a:rPr sz="900" b="1">
-                <a:solidFill>
-                  <a:srgbClr val="198B83"/>
-                </a:solidFill>
-                <a:latin typeface="Aptos"/>
-              </a:rPr>
-              <a:t>01</a:t>
-            </a:r>
-          </a:p>
-        </p:txBody>
-      </p:sp>
-      <p:sp>
-        <p:nvSpPr>
-          <p:cNvPr id="18" name="TextBox 17"/>
-          <p:cNvSpPr txBox="1"/>
-          <p:nvPr/>
-        </p:nvSpPr>
-        <p:spPr>
-          <a:xfrm>
-            <a:off x="658368" y="4133087"/>
-            <a:ext cx="1600200" cy="256032"/>
-          </a:xfrm>
-          <a:prstGeom prst="rect">
-            <a:avLst/>
-          </a:prstGeom>
-          <a:noFill/>
-        </p:spPr>
-        <p:txBody>
-          <a:bodyPr wrap="none" lIns="18288" rIns="18288" anchor="ctr">
-            <a:spAutoFit/>
-          </a:bodyPr>
-          <a:lstStyle/>
-          <a:p>
-            <a:pPr algn="l"/>
-            <a:r>
-              <a:rPr sz="1200" b="1">
-                <a:solidFill>
-                  <a:srgbClr val="172D3A"/>
-                </a:solidFill>
-                <a:latin typeface="Aptos"/>
-              </a:rPr>
-              <a:t>Validate</a:t>
-            </a:r>
-          </a:p>
-        </p:txBody>
-      </p:sp>
-      <p:sp>
-        <p:nvSpPr>
-          <p:cNvPr id="19" name="TextBox 18"/>
-          <p:cNvSpPr txBox="1"/>
-          <p:nvPr/>
-        </p:nvSpPr>
-        <p:spPr>
-          <a:xfrm>
-            <a:off x="658368" y="4462272"/>
-            <a:ext cx="1645920" cy="320040"/>
-          </a:xfrm>
-          <a:prstGeom prst="rect">
-            <a:avLst/>
-          </a:prstGeom>
-          <a:noFill/>
-        </p:spPr>
-        <p:txBody>
-          <a:bodyPr wrap="none" lIns="18288" rIns="18288" anchor="ctr">
-            <a:spAutoFit/>
-          </a:bodyPr>
-          <a:lstStyle/>
-          <a:p>
-            <a:pPr algn="l"/>
-            <a:r>
-              <a:rPr sz="900" b="0">
-                <a:solidFill>
-                  <a:srgbClr val="6F7E88"/>
-                </a:solidFill>
-                <a:latin typeface="Aptos"/>
-              </a:rPr>
-              <a:t>types + schema</a:t>
-            </a:r>
-          </a:p>
-        </p:txBody>
-      </p:sp>
-      <p:sp>
-        <p:nvSpPr>
-          <p:cNvPr id="20" name="TextBox 19"/>
-          <p:cNvSpPr txBox="1"/>
-          <p:nvPr/>
-        </p:nvSpPr>
-        <p:spPr>
-          <a:xfrm>
-            <a:off x="2331720" y="4114800"/>
-            <a:ext cx="274320" cy="274320"/>
-          </a:xfrm>
-          <a:prstGeom prst="rect">
-            <a:avLst/>
-          </a:prstGeom>
-          <a:noFill/>
-        </p:spPr>
-        <p:txBody>
-          <a:bodyPr wrap="none" lIns="18288" rIns="18288" anchor="ctr">
-            <a:spAutoFit/>
-          </a:bodyPr>
-          <a:lstStyle/>
-          <a:p>
-            <a:pPr algn="l"/>
-            <a:r>
-              <a:rPr sz="1600" b="1">
-                <a:solidFill>
-                  <a:srgbClr val="EF7C63"/>
-                </a:solidFill>
-                <a:latin typeface="Aptos"/>
-              </a:rPr>
-              <a:t>→</a:t>
-            </a:r>
-          </a:p>
-        </p:txBody>
-      </p:sp>
-      <p:sp>
-        <p:nvSpPr>
-          <p:cNvPr id="21" name="TextBox 20"/>
-          <p:cNvSpPr txBox="1"/>
-          <p:nvPr/>
-        </p:nvSpPr>
-        <p:spPr>
-          <a:xfrm>
-            <a:off x="2871215" y="3813048"/>
-            <a:ext cx="320040" cy="219456"/>
-          </a:xfrm>
-          <a:prstGeom prst="rect">
-            <a:avLst/>
-          </a:prstGeom>
-          <a:noFill/>
-        </p:spPr>
-        <p:txBody>
-          <a:bodyPr wrap="none" lIns="18288" rIns="18288" anchor="ctr">
-            <a:spAutoFit/>
-          </a:bodyPr>
-          <a:lstStyle/>
-          <a:p>
-            <a:pPr algn="l"/>
-            <a:r>
-              <a:rPr sz="900" b="1">
-                <a:solidFill>
-                  <a:srgbClr val="198B83"/>
-                </a:solidFill>
-                <a:latin typeface="Aptos"/>
-              </a:rPr>
-              <a:t>02</a:t>
-            </a:r>
-          </a:p>
-        </p:txBody>
-      </p:sp>
-      <p:sp>
-        <p:nvSpPr>
-          <p:cNvPr id="22" name="TextBox 21"/>
-          <p:cNvSpPr txBox="1"/>
-          <p:nvPr/>
-        </p:nvSpPr>
-        <p:spPr>
-          <a:xfrm>
-            <a:off x="2871215" y="4133087"/>
-            <a:ext cx="1600200" cy="256032"/>
-          </a:xfrm>
-          <a:prstGeom prst="rect">
-            <a:avLst/>
-          </a:prstGeom>
-          <a:noFill/>
-        </p:spPr>
-        <p:txBody>
-          <a:bodyPr wrap="none" lIns="18288" rIns="18288" anchor="ctr">
-            <a:spAutoFit/>
-          </a:bodyPr>
-          <a:lstStyle/>
-          <a:p>
-            <a:pPr algn="l"/>
-            <a:r>
-              <a:rPr sz="1200" b="1">
-                <a:solidFill>
-                  <a:srgbClr val="172D3A"/>
-                </a:solidFill>
-                <a:latin typeface="Aptos"/>
-              </a:rPr>
-              <a:t>Impute</a:t>
-            </a:r>
-          </a:p>
-        </p:txBody>
-      </p:sp>
-      <p:sp>
-        <p:nvSpPr>
-          <p:cNvPr id="23" name="TextBox 22"/>
-          <p:cNvSpPr txBox="1"/>
-          <p:nvPr/>
-        </p:nvSpPr>
-        <p:spPr>
-          <a:xfrm>
-            <a:off x="2871215" y="4462272"/>
-            <a:ext cx="1645920" cy="320040"/>
-          </a:xfrm>
-          <a:prstGeom prst="rect">
-            <a:avLst/>
-          </a:prstGeom>
-          <a:noFill/>
-        </p:spPr>
-        <p:txBody>
-          <a:bodyPr wrap="none" lIns="18288" rIns="18288" anchor="ctr">
-            <a:spAutoFit/>
-          </a:bodyPr>
-          <a:lstStyle/>
-          <a:p>
-            <a:pPr algn="l"/>
-            <a:r>
-              <a:rPr sz="900" b="0">
-                <a:solidFill>
-                  <a:srgbClr val="6F7E88"/>
-                </a:solidFill>
-                <a:latin typeface="Aptos"/>
-              </a:rPr>
-              <a:t>median / mode</a:t>
-            </a:r>
-          </a:p>
-        </p:txBody>
-      </p:sp>
-      <p:sp>
-        <p:nvSpPr>
-          <p:cNvPr id="24" name="TextBox 23"/>
-          <p:cNvSpPr txBox="1"/>
-          <p:nvPr/>
-        </p:nvSpPr>
-        <p:spPr>
-          <a:xfrm>
-            <a:off x="4544568" y="4114800"/>
-            <a:ext cx="274320" cy="274320"/>
-          </a:xfrm>
-          <a:prstGeom prst="rect">
-            <a:avLst/>
-          </a:prstGeom>
-          <a:noFill/>
-        </p:spPr>
-        <p:txBody>
-          <a:bodyPr wrap="none" lIns="18288" rIns="18288" anchor="ctr">
-            <a:spAutoFit/>
-          </a:bodyPr>
-          <a:lstStyle/>
-          <a:p>
-            <a:pPr algn="l"/>
-            <a:r>
-              <a:rPr sz="1600" b="1">
-                <a:solidFill>
-                  <a:srgbClr val="EF7C63"/>
-                </a:solidFill>
-                <a:latin typeface="Aptos"/>
-              </a:rPr>
-              <a:t>→</a:t>
-            </a:r>
-          </a:p>
-        </p:txBody>
-      </p:sp>
-      <p:sp>
-        <p:nvSpPr>
-          <p:cNvPr id="25" name="TextBox 24"/>
-          <p:cNvSpPr txBox="1"/>
-          <p:nvPr/>
-        </p:nvSpPr>
-        <p:spPr>
-          <a:xfrm>
-            <a:off x="5084064" y="3813048"/>
-            <a:ext cx="320040" cy="219456"/>
-          </a:xfrm>
-          <a:prstGeom prst="rect">
-            <a:avLst/>
-          </a:prstGeom>
-          <a:noFill/>
-        </p:spPr>
-        <p:txBody>
-          <a:bodyPr wrap="none" lIns="18288" rIns="18288" anchor="ctr">
-            <a:spAutoFit/>
-          </a:bodyPr>
-          <a:lstStyle/>
-          <a:p>
-            <a:pPr algn="l"/>
-            <a:r>
-              <a:rPr sz="900" b="1">
-                <a:solidFill>
-                  <a:srgbClr val="198B83"/>
-                </a:solidFill>
-                <a:latin typeface="Aptos"/>
-              </a:rPr>
-              <a:t>03</a:t>
-            </a:r>
-          </a:p>
-        </p:txBody>
-      </p:sp>
-      <p:sp>
-        <p:nvSpPr>
-          <p:cNvPr id="26" name="TextBox 25"/>
-          <p:cNvSpPr txBox="1"/>
-          <p:nvPr/>
-        </p:nvSpPr>
-        <p:spPr>
-          <a:xfrm>
-            <a:off x="5084064" y="4133087"/>
-            <a:ext cx="1600200" cy="256032"/>
-          </a:xfrm>
-          <a:prstGeom prst="rect">
-            <a:avLst/>
-          </a:prstGeom>
-          <a:noFill/>
-        </p:spPr>
-        <p:txBody>
-          <a:bodyPr wrap="none" lIns="18288" rIns="18288" anchor="ctr">
-            <a:spAutoFit/>
-          </a:bodyPr>
-          <a:lstStyle/>
-          <a:p>
-            <a:pPr algn="l"/>
-            <a:r>
-              <a:rPr sz="1200" b="1">
-                <a:solidFill>
-                  <a:srgbClr val="172D3A"/>
-                </a:solidFill>
-                <a:latin typeface="Aptos"/>
-              </a:rPr>
-              <a:t>Encode</a:t>
-            </a:r>
-          </a:p>
-        </p:txBody>
-      </p:sp>
-      <p:sp>
-        <p:nvSpPr>
-          <p:cNvPr id="27" name="TextBox 26"/>
-          <p:cNvSpPr txBox="1"/>
-          <p:nvPr/>
-        </p:nvSpPr>
-        <p:spPr>
-          <a:xfrm>
-            <a:off x="5084064" y="4462272"/>
-            <a:ext cx="1645920" cy="320040"/>
-          </a:xfrm>
-          <a:prstGeom prst="rect">
-            <a:avLst/>
-          </a:prstGeom>
-          <a:noFill/>
-        </p:spPr>
-        <p:txBody>
-          <a:bodyPr wrap="none" lIns="18288" rIns="18288" anchor="ctr">
-            <a:spAutoFit/>
-          </a:bodyPr>
-          <a:lstStyle/>
-          <a:p>
-            <a:pPr algn="l"/>
-            <a:r>
-              <a:rPr sz="900" b="0">
-                <a:solidFill>
-                  <a:srgbClr val="6F7E88"/>
-                </a:solidFill>
-                <a:latin typeface="Aptos"/>
-              </a:rPr>
-              <a:t>one-hot categories</a:t>
-            </a:r>
-          </a:p>
-        </p:txBody>
-      </p:sp>
-      <p:sp>
-        <p:nvSpPr>
-          <p:cNvPr id="28" name="TextBox 27"/>
-          <p:cNvSpPr txBox="1"/>
-          <p:nvPr/>
-        </p:nvSpPr>
-        <p:spPr>
-          <a:xfrm>
-            <a:off x="6757416" y="4114800"/>
-            <a:ext cx="274320" cy="274320"/>
-          </a:xfrm>
-          <a:prstGeom prst="rect">
-            <a:avLst/>
-          </a:prstGeom>
-          <a:noFill/>
-        </p:spPr>
-        <p:txBody>
-          <a:bodyPr wrap="none" lIns="18288" rIns="18288" anchor="ctr">
-            <a:spAutoFit/>
-          </a:bodyPr>
-          <a:lstStyle/>
-          <a:p>
-            <a:pPr algn="l"/>
-            <a:r>
-              <a:rPr sz="1600" b="1">
-                <a:solidFill>
-                  <a:srgbClr val="EF7C63"/>
-                </a:solidFill>
-                <a:latin typeface="Aptos"/>
-              </a:rPr>
-              <a:t>→</a:t>
-            </a:r>
-          </a:p>
-        </p:txBody>
-      </p:sp>
-      <p:sp>
-        <p:nvSpPr>
-          <p:cNvPr id="29" name="TextBox 28"/>
-          <p:cNvSpPr txBox="1"/>
-          <p:nvPr/>
-        </p:nvSpPr>
-        <p:spPr>
-          <a:xfrm>
-            <a:off x="7296912" y="3813048"/>
-            <a:ext cx="320040" cy="219456"/>
-          </a:xfrm>
-          <a:prstGeom prst="rect">
-            <a:avLst/>
-          </a:prstGeom>
-          <a:noFill/>
-        </p:spPr>
-        <p:txBody>
-          <a:bodyPr wrap="none" lIns="18288" rIns="18288" anchor="ctr">
-            <a:spAutoFit/>
-          </a:bodyPr>
-          <a:lstStyle/>
-          <a:p>
-            <a:pPr algn="l"/>
-            <a:r>
-              <a:rPr sz="900" b="1">
-                <a:solidFill>
-                  <a:srgbClr val="198B83"/>
-                </a:solidFill>
-                <a:latin typeface="Aptos"/>
-              </a:rPr>
-              <a:t>04</a:t>
-            </a:r>
-          </a:p>
-        </p:txBody>
-      </p:sp>
-      <p:sp>
-        <p:nvSpPr>
-          <p:cNvPr id="30" name="TextBox 29"/>
-          <p:cNvSpPr txBox="1"/>
-          <p:nvPr/>
-        </p:nvSpPr>
-        <p:spPr>
-          <a:xfrm>
-            <a:off x="7296912" y="4133087"/>
-            <a:ext cx="1600200" cy="256032"/>
-          </a:xfrm>
-          <a:prstGeom prst="rect">
-            <a:avLst/>
-          </a:prstGeom>
-          <a:noFill/>
-        </p:spPr>
-        <p:txBody>
-          <a:bodyPr wrap="none" lIns="18288" rIns="18288" anchor="ctr">
-            <a:spAutoFit/>
-          </a:bodyPr>
-          <a:lstStyle/>
-          <a:p>
-            <a:pPr algn="l"/>
-            <a:r>
-              <a:rPr sz="1200" b="1">
-                <a:solidFill>
-                  <a:srgbClr val="172D3A"/>
-                </a:solidFill>
-                <a:latin typeface="Aptos"/>
-              </a:rPr>
-              <a:t>Clip + scale</a:t>
-            </a:r>
-          </a:p>
-        </p:txBody>
-      </p:sp>
-      <p:sp>
-        <p:nvSpPr>
-          <p:cNvPr id="31" name="TextBox 30"/>
-          <p:cNvSpPr txBox="1"/>
-          <p:nvPr/>
-        </p:nvSpPr>
-        <p:spPr>
-          <a:xfrm>
-            <a:off x="7296912" y="4462272"/>
-            <a:ext cx="1645920" cy="320040"/>
-          </a:xfrm>
-          <a:prstGeom prst="rect">
-            <a:avLst/>
-          </a:prstGeom>
-          <a:noFill/>
-        </p:spPr>
-        <p:txBody>
-          <a:bodyPr wrap="none" lIns="18288" rIns="18288" anchor="ctr">
-            <a:spAutoFit/>
-          </a:bodyPr>
-          <a:lstStyle/>
-          <a:p>
-            <a:pPr algn="l"/>
-            <a:r>
-              <a:rPr sz="900" b="0">
-                <a:solidFill>
-                  <a:srgbClr val="6F7E88"/>
-                </a:solidFill>
-                <a:latin typeface="Aptos"/>
-              </a:rPr>
-              <a:t>IQR + standardize</a:t>
-            </a:r>
-          </a:p>
-        </p:txBody>
-      </p:sp>
-      <p:sp>
-        <p:nvSpPr>
-          <p:cNvPr id="32" name="TextBox 31"/>
-          <p:cNvSpPr txBox="1"/>
-          <p:nvPr/>
-        </p:nvSpPr>
-        <p:spPr>
-          <a:xfrm>
-            <a:off x="8970263" y="4114800"/>
-            <a:ext cx="274320" cy="274320"/>
-          </a:xfrm>
-          <a:prstGeom prst="rect">
-            <a:avLst/>
-          </a:prstGeom>
-          <a:noFill/>
-        </p:spPr>
-        <p:txBody>
-          <a:bodyPr wrap="none" lIns="18288" rIns="18288" anchor="ctr">
-            <a:spAutoFit/>
-          </a:bodyPr>
-          <a:lstStyle/>
-          <a:p>
-            <a:pPr algn="l"/>
-            <a:r>
-              <a:rPr sz="1600" b="1">
-                <a:solidFill>
-                  <a:srgbClr val="EF7C63"/>
-                </a:solidFill>
-                <a:latin typeface="Aptos"/>
-              </a:rPr>
-              <a:t>→</a:t>
-            </a:r>
-          </a:p>
-        </p:txBody>
-      </p:sp>
-      <p:sp>
-        <p:nvSpPr>
-          <p:cNvPr id="33" name="TextBox 32"/>
-          <p:cNvSpPr txBox="1"/>
-          <p:nvPr/>
-        </p:nvSpPr>
-        <p:spPr>
-          <a:xfrm>
-            <a:off x="9509760" y="3813048"/>
-            <a:ext cx="320040" cy="219456"/>
-          </a:xfrm>
-          <a:prstGeom prst="rect">
-            <a:avLst/>
-          </a:prstGeom>
-          <a:noFill/>
-        </p:spPr>
-        <p:txBody>
-          <a:bodyPr wrap="none" lIns="18288" rIns="18288" anchor="ctr">
-            <a:spAutoFit/>
-          </a:bodyPr>
-          <a:lstStyle/>
-          <a:p>
-            <a:pPr algn="l"/>
-            <a:r>
-              <a:rPr sz="900" b="1">
-                <a:solidFill>
-                  <a:srgbClr val="198B83"/>
-                </a:solidFill>
-                <a:latin typeface="Aptos"/>
-              </a:rPr>
-              <a:t>05</a:t>
-            </a:r>
-          </a:p>
-        </p:txBody>
-      </p:sp>
-      <p:sp>
-        <p:nvSpPr>
-          <p:cNvPr id="34" name="TextBox 33"/>
-          <p:cNvSpPr txBox="1"/>
-          <p:nvPr/>
-        </p:nvSpPr>
-        <p:spPr>
-          <a:xfrm>
-            <a:off x="9509760" y="4133087"/>
-            <a:ext cx="1600200" cy="256032"/>
-          </a:xfrm>
-          <a:prstGeom prst="rect">
-            <a:avLst/>
-          </a:prstGeom>
-          <a:noFill/>
-        </p:spPr>
-        <p:txBody>
-          <a:bodyPr wrap="none" lIns="18288" rIns="18288" anchor="ctr">
-            <a:spAutoFit/>
-          </a:bodyPr>
-          <a:lstStyle/>
-          <a:p>
-            <a:pPr algn="l"/>
-            <a:r>
-              <a:rPr sz="1200" b="1">
-                <a:solidFill>
-                  <a:srgbClr val="172D3A"/>
-                </a:solidFill>
-                <a:latin typeface="Aptos"/>
-              </a:rPr>
-              <a:t>Fit</a:t>
-            </a:r>
-          </a:p>
-        </p:txBody>
-      </p:sp>
-      <p:sp>
-        <p:nvSpPr>
-          <p:cNvPr id="35" name="TextBox 34"/>
-          <p:cNvSpPr txBox="1"/>
-          <p:nvPr/>
-        </p:nvSpPr>
-        <p:spPr>
-          <a:xfrm>
-            <a:off x="9509760" y="4462272"/>
-            <a:ext cx="1645920" cy="320040"/>
-          </a:xfrm>
-          <a:prstGeom prst="rect">
-            <a:avLst/>
-          </a:prstGeom>
-          <a:noFill/>
-        </p:spPr>
-        <p:txBody>
-          <a:bodyPr wrap="none" lIns="18288" rIns="18288" anchor="ctr">
-            <a:spAutoFit/>
-          </a:bodyPr>
-          <a:lstStyle/>
-          <a:p>
-            <a:pPr algn="l"/>
-            <a:r>
-              <a:rPr sz="900" b="0">
-                <a:solidFill>
-                  <a:srgbClr val="6F7E88"/>
-                </a:solidFill>
-                <a:latin typeface="Aptos"/>
-              </a:rPr>
-              <a:t>two ensembles</a:t>
-            </a:r>
-          </a:p>
-        </p:txBody>
-      </p:sp>
-      <p:sp>
-        <p:nvSpPr>
-          <p:cNvPr id="36" name="Rounded Rectangle 35"/>
+              <a:t>In this held-out test, Gradient Boosting edges ahead on ROC-AUC and recall. Random Forest has the higher precision.</a:t>
+            </a:r>
+          </a:p>
+        </p:txBody>
+      </p:sp>
+      <p:sp>
+        <p:nvSpPr>
+          <p:cNvPr id="11" name="Rectangle 10"/>
           <p:cNvSpPr/>
           <p:nvPr/>
         </p:nvSpPr>
         <p:spPr>
           <a:xfrm>
-            <a:off x="658368" y="5138928"/>
-            <a:ext cx="10835640" cy="566928"/>
-          </a:xfrm>
-          <a:prstGeom prst="roundRect">
+            <a:off x="4526280" y="945514"/>
+            <a:ext cx="7178040" cy="5012690"/>
+          </a:xfrm>
+          <a:prstGeom prst="rect">
             <a:avLst/>
           </a:prstGeom>
           <a:solidFill>
-            <a:srgbClr val="172D3A"/>
+            <a:srgbClr val="F7FAF5"/>
           </a:solidFill>
-          <a:ln w="8890">
+          <a:ln w="7620">
             <a:solidFill>
-              <a:srgbClr val="172D3A"/>
+              <a:srgbClr val="B8C5BC"/>
             </a:solidFill>
           </a:ln>
         </p:spPr>
@@ -4719,111 +4488,30 @@
           </a:p>
         </p:txBody>
       </p:sp>
-      <p:sp>
-        <p:nvSpPr>
-          <p:cNvPr id="37" name="TextBox 36"/>
-          <p:cNvSpPr txBox="1"/>
+      <p:pic>
+        <p:nvPicPr>
+          <p:cNvPr id="12" name="Picture 11" descr="03-compare-models.png"/>
+          <p:cNvPicPr>
+            <a:picLocks noChangeAspect="1"/>
+          </p:cNvPicPr>
           <p:nvPr/>
-        </p:nvSpPr>
-        <p:spPr>
-          <a:xfrm>
-            <a:off x="868680" y="5276088"/>
-            <a:ext cx="10332720" cy="237744"/>
-          </a:xfrm>
-          <a:prstGeom prst="rect">
-            <a:avLst/>
-          </a:prstGeom>
-          <a:noFill/>
-        </p:spPr>
-        <p:txBody>
-          <a:bodyPr wrap="none" lIns="18288" rIns="18288" anchor="ctr">
-            <a:spAutoFit/>
-          </a:bodyPr>
-          <a:lstStyle/>
-          <a:p>
-            <a:pPr algn="l"/>
-            <a:r>
-              <a:rPr sz="1100" b="1">
-                <a:solidFill>
-                  <a:srgbClr val="FFFFFF"/>
-                </a:solidFill>
-                <a:latin typeface="Aptos"/>
-              </a:rPr>
-              <a:t>Random Forest averages independent tree votes. Gradient Boosting corrects earlier tree errors sequentially.</a:t>
-            </a:r>
-          </a:p>
-        </p:txBody>
-      </p:sp>
-      <p:sp>
-        <p:nvSpPr>
-          <p:cNvPr id="38" name="TextBox 37"/>
-          <p:cNvSpPr txBox="1"/>
-          <p:nvPr/>
-        </p:nvSpPr>
-        <p:spPr>
-          <a:xfrm>
-            <a:off x="502920" y="6473952"/>
-            <a:ext cx="5029200" cy="228600"/>
-          </a:xfrm>
-          <a:prstGeom prst="rect">
-            <a:avLst/>
-          </a:prstGeom>
-          <a:noFill/>
-        </p:spPr>
-        <p:txBody>
-          <a:bodyPr wrap="none" lIns="18288" rIns="18288" anchor="ctr">
-            <a:spAutoFit/>
-          </a:bodyPr>
-          <a:lstStyle/>
-          <a:p>
-            <a:pPr algn="l"/>
-            <a:r>
-              <a:rPr sz="700" b="1">
-                <a:solidFill>
-                  <a:srgbClr val="6F7E88"/>
-                </a:solidFill>
-                <a:latin typeface="Aptos"/>
-              </a:rPr>
-              <a:t>DIABETES ENSEMBLE LAB  •  MINI-PROJECT</a:t>
-            </a:r>
-          </a:p>
-        </p:txBody>
-      </p:sp>
-      <p:sp>
-        <p:nvSpPr>
-          <p:cNvPr id="39" name="TextBox 38"/>
-          <p:cNvSpPr txBox="1"/>
-          <p:nvPr/>
-        </p:nvSpPr>
-        <p:spPr>
-          <a:xfrm>
-            <a:off x="10881360" y="6473952"/>
-            <a:ext cx="777240" cy="228600"/>
-          </a:xfrm>
-          <a:prstGeom prst="rect">
-            <a:avLst/>
-          </a:prstGeom>
-          <a:noFill/>
-        </p:spPr>
-        <p:txBody>
-          <a:bodyPr wrap="none" lIns="18288" rIns="18288" anchor="ctr">
-            <a:spAutoFit/>
-          </a:bodyPr>
-          <a:lstStyle/>
-          <a:p>
-            <a:pPr algn="r"/>
-            <a:r>
-              <a:rPr sz="700" b="1">
-                <a:solidFill>
-                  <a:srgbClr val="6F7E88"/>
-                </a:solidFill>
-                <a:latin typeface="Aptos"/>
-              </a:rPr>
-              <a:t>02 / 04</a:t>
-            </a:r>
-          </a:p>
-        </p:txBody>
-      </p:sp>
+        </p:nvPicPr>
+        <p:blipFill>
+          <a:blip r:embed="rId2"/>
+          <a:stretch>
+            <a:fillRect/>
+          </a:stretch>
+        </p:blipFill>
+        <p:spPr>
+          <a:xfrm>
+            <a:off x="4572000" y="991234"/>
+            <a:ext cx="7086600" cy="4921250"/>
+          </a:xfrm>
+          <a:prstGeom prst="rect">
+            <a:avLst/>
+          </a:prstGeom>
+        </p:spPr>
+      </p:pic>
     </p:spTree>
   </p:cSld>
   <p:clrMapOvr>
@@ -4832,13 +4520,13 @@
 </p:sld>
 </file>
 
-<file path=ppt/slides/slide3.xml><?xml version="1.0" encoding="utf-8"?>
+<file path=ppt/slides/slide4.xml><?xml version="1.0" encoding="utf-8"?>
 <p:sld xmlns:a="http://schemas.openxmlformats.org/drawingml/2006/main" xmlns:p="http://schemas.openxmlformats.org/presentationml/2006/main" xmlns:r="http://schemas.openxmlformats.org/officeDocument/2006/relationships">
   <p:cSld>
     <p:bg>
       <p:bgPr>
         <a:solidFill>
-          <a:srgbClr val="FFFFFF"/>
+          <a:srgbClr val="E5E8E1"/>
         </a:solidFill>
         <a:effectLst/>
       </p:bgPr>
@@ -4858,8 +4546,8 @@
         </p:nvSpPr>
         <p:spPr>
           <a:xfrm>
-            <a:off x="594360" y="475488"/>
-            <a:ext cx="4114800" cy="228600"/>
+            <a:off x="502920" y="256032"/>
+            <a:ext cx="2926080" cy="182880"/>
           </a:xfrm>
           <a:prstGeom prst="rect">
             <a:avLst/>
@@ -4874,13 +4562,13 @@
           <a:p>
             <a:pPr algn="l"/>
             <a:r>
-              <a:rPr sz="900" b="1">
-                <a:solidFill>
-                  <a:srgbClr val="198B83"/>
+              <a:rPr sz="800" b="1">
+                <a:solidFill>
+                  <a:srgbClr val="05685F"/>
                 </a:solidFill>
                 <a:latin typeface="Aptos"/>
               </a:rPr>
-              <a:t>02  /  RESULTS</a:t>
+              <a:t>DIABETES MODEL STUDY</a:t>
             </a:r>
           </a:p>
         </p:txBody>
@@ -4893,8 +4581,8 @@
         </p:nvSpPr>
         <p:spPr>
           <a:xfrm>
-            <a:off x="594360" y="841248"/>
-            <a:ext cx="7315200" cy="502920"/>
+            <a:off x="8229600" y="256032"/>
+            <a:ext cx="3200400" cy="182880"/>
           </a:xfrm>
           <a:prstGeom prst="rect">
             <a:avLst/>
@@ -4907,15 +4595,15 @@
           </a:bodyPr>
           <a:lstStyle/>
           <a:p>
-            <a:pPr algn="l"/>
-            <a:r>
-              <a:rPr sz="2400" b="1">
-                <a:solidFill>
-                  <a:srgbClr val="172D3A"/>
+            <a:pPr algn="r"/>
+            <a:r>
+              <a:rPr sz="800" b="0">
+                <a:solidFill>
+                  <a:srgbClr val="35514C"/>
                 </a:solidFill>
                 <a:latin typeface="Aptos"/>
               </a:rPr>
-              <a:t>Compare more than accuracy.</a:t>
+              <a:t>Understand the data</a:t>
             </a:r>
           </a:p>
         </p:txBody>
@@ -4928,8 +4616,8 @@
         </p:nvSpPr>
         <p:spPr>
           <a:xfrm>
-            <a:off x="612648" y="1389888"/>
-            <a:ext cx="6400800" cy="274320"/>
+            <a:off x="10972800" y="6519672"/>
+            <a:ext cx="685800" cy="164592"/>
           </a:xfrm>
           <a:prstGeom prst="rect">
             <a:avLst/>
@@ -4942,15 +4630,15 @@
           </a:bodyPr>
           <a:lstStyle/>
           <a:p>
-            <a:pPr algn="l"/>
-            <a:r>
-              <a:rPr sz="1000" b="0">
-                <a:solidFill>
-                  <a:srgbClr val="6F7E88"/>
+            <a:pPr algn="r"/>
+            <a:r>
+              <a:rPr sz="800" b="1">
+                <a:solidFill>
+                  <a:srgbClr val="35514C"/>
                 </a:solidFill>
                 <a:latin typeface="Aptos"/>
               </a:rPr>
-              <a:t>Held-out validation metrics after randomized hyperparameter search</a:t>
+              <a:t>04 / 04</a:t>
             </a:r>
           </a:p>
         </p:txBody>
@@ -4963,8 +4651,8 @@
         </p:nvSpPr>
         <p:spPr>
           <a:xfrm>
-            <a:off x="777240" y="1947672"/>
-            <a:ext cx="3108960" cy="228600"/>
+            <a:off x="502920" y="6519672"/>
+            <a:ext cx="4114800" cy="164592"/>
           </a:xfrm>
           <a:prstGeom prst="rect">
             <a:avLst/>
@@ -4979,13 +4667,13 @@
           <a:p>
             <a:pPr algn="l"/>
             <a:r>
-              <a:rPr sz="800" b="1">
-                <a:solidFill>
-                  <a:srgbClr val="6F7E88"/>
+              <a:rPr sz="800" b="0">
+                <a:solidFill>
+                  <a:srgbClr val="35514C"/>
                 </a:solidFill>
                 <a:latin typeface="Aptos"/>
               </a:rPr>
-              <a:t>METRIC</a:t>
+              <a:t>Working Next.js prototype · educational use only</a:t>
             </a:r>
           </a:p>
         </p:txBody>
@@ -4998,8 +4686,8 @@
         </p:nvSpPr>
         <p:spPr>
           <a:xfrm>
-            <a:off x="4069080" y="1947672"/>
-            <a:ext cx="3108960" cy="228600"/>
+            <a:off x="502920" y="960120"/>
+            <a:ext cx="3749039" cy="1097280"/>
           </a:xfrm>
           <a:prstGeom prst="rect">
             <a:avLst/>
@@ -5014,13 +4702,14 @@
           <a:p>
             <a:pPr algn="l"/>
             <a:r>
-              <a:rPr sz="800" b="1">
-                <a:solidFill>
-                  <a:srgbClr val="6F7E88"/>
-                </a:solidFill>
-                <a:latin typeface="Aptos"/>
+              <a:rPr sz="2900" b="0">
+                <a:solidFill>
+                  <a:srgbClr val="172F2D"/>
+                </a:solidFill>
+                <a:latin typeface="Georgia"/>
               </a:rPr>
-              <a:t>RANDOM FOREST</a:t>
+              <a:t>What the models
+are allowed to see.</a:t>
             </a:r>
           </a:p>
         </p:txBody>
@@ -5033,8 +4722,8 @@
         </p:nvSpPr>
         <p:spPr>
           <a:xfrm>
-            <a:off x="7635240" y="1947672"/>
-            <a:ext cx="3108960" cy="228600"/>
+            <a:off x="530352" y="2395728"/>
+            <a:ext cx="3474720" cy="292608"/>
           </a:xfrm>
           <a:prstGeom prst="rect">
             <a:avLst/>
@@ -5049,13 +4738,13 @@
           <a:p>
             <a:pPr algn="l"/>
             <a:r>
-              <a:rPr sz="800" b="1">
-                <a:solidFill>
-                  <a:srgbClr val="6F7E88"/>
+              <a:rPr sz="1600" b="1">
+                <a:solidFill>
+                  <a:srgbClr val="05685F"/>
                 </a:solidFill>
                 <a:latin typeface="Aptos"/>
               </a:rPr>
-              <a:t>GRADIENT BOOSTING</a:t>
+              <a:t>The study context</a:t>
             </a:r>
           </a:p>
         </p:txBody>
@@ -5068,8 +4757,8 @@
         </p:nvSpPr>
         <p:spPr>
           <a:xfrm>
-            <a:off x="777240" y="2331720"/>
-            <a:ext cx="2194560" cy="274320"/>
+            <a:off x="530352" y="2834640"/>
+            <a:ext cx="164592" cy="219456"/>
           </a:xfrm>
           <a:prstGeom prst="rect">
             <a:avLst/>
@@ -5084,37 +4773,212 @@
           <a:p>
             <a:pPr algn="l"/>
             <a:r>
-              <a:rPr sz="1100" b="0">
-                <a:solidFill>
-                  <a:srgbClr val="2C3D48"/>
+              <a:rPr sz="1600" b="1">
+                <a:solidFill>
+                  <a:srgbClr val="A8443F"/>
                 </a:solidFill>
                 <a:latin typeface="Aptos"/>
               </a:rPr>
-              <a:t>Accuracy</a:t>
-            </a:r>
-          </a:p>
-        </p:txBody>
-      </p:sp>
-      <p:sp>
-        <p:nvSpPr>
-          <p:cNvPr id="9" name="Rounded Rectangle 8"/>
+              <a:t>•</a:t>
+            </a:r>
+          </a:p>
+        </p:txBody>
+      </p:sp>
+      <p:sp>
+        <p:nvSpPr>
+          <p:cNvPr id="9" name="TextBox 8"/>
+          <p:cNvSpPr txBox="1"/>
+          <p:nvPr/>
+        </p:nvSpPr>
+        <p:spPr>
+          <a:xfrm>
+            <a:off x="786384" y="2825496"/>
+            <a:ext cx="3264408" cy="457200"/>
+          </a:xfrm>
+          <a:prstGeom prst="rect">
+            <a:avLst/>
+          </a:prstGeom>
+          <a:noFill/>
+        </p:spPr>
+        <p:txBody>
+          <a:bodyPr wrap="none" lIns="18288" rIns="18288" anchor="ctr">
+            <a:spAutoFit/>
+          </a:bodyPr>
+          <a:lstStyle/>
+          <a:p>
+            <a:pPr algn="l"/>
+            <a:r>
+              <a:rPr sz="1300" b="0">
+                <a:solidFill>
+                  <a:srgbClr val="172F2D"/>
+                </a:solidFill>
+                <a:latin typeface="Aptos"/>
+              </a:rPr>
+              <a:t>100,000 records and 20,000 held out for testing.</a:t>
+            </a:r>
+          </a:p>
+        </p:txBody>
+      </p:sp>
+      <p:sp>
+        <p:nvSpPr>
+          <p:cNvPr id="10" name="TextBox 9"/>
+          <p:cNvSpPr txBox="1"/>
+          <p:nvPr/>
+        </p:nvSpPr>
+        <p:spPr>
+          <a:xfrm>
+            <a:off x="530352" y="3493008"/>
+            <a:ext cx="164592" cy="219456"/>
+          </a:xfrm>
+          <a:prstGeom prst="rect">
+            <a:avLst/>
+          </a:prstGeom>
+          <a:noFill/>
+        </p:spPr>
+        <p:txBody>
+          <a:bodyPr wrap="none" lIns="18288" rIns="18288" anchor="ctr">
+            <a:spAutoFit/>
+          </a:bodyPr>
+          <a:lstStyle/>
+          <a:p>
+            <a:pPr algn="l"/>
+            <a:r>
+              <a:rPr sz="1600" b="1">
+                <a:solidFill>
+                  <a:srgbClr val="A8443F"/>
+                </a:solidFill>
+                <a:latin typeface="Aptos"/>
+              </a:rPr>
+              <a:t>•</a:t>
+            </a:r>
+          </a:p>
+        </p:txBody>
+      </p:sp>
+      <p:sp>
+        <p:nvSpPr>
+          <p:cNvPr id="11" name="TextBox 10"/>
+          <p:cNvSpPr txBox="1"/>
+          <p:nvPr/>
+        </p:nvSpPr>
+        <p:spPr>
+          <a:xfrm>
+            <a:off x="786384" y="3483864"/>
+            <a:ext cx="3264408" cy="457200"/>
+          </a:xfrm>
+          <a:prstGeom prst="rect">
+            <a:avLst/>
+          </a:prstGeom>
+          <a:noFill/>
+        </p:spPr>
+        <p:txBody>
+          <a:bodyPr wrap="none" lIns="18288" rIns="18288" anchor="ctr">
+            <a:spAutoFit/>
+          </a:bodyPr>
+          <a:lstStyle/>
+          <a:p>
+            <a:pPr algn="l"/>
+            <a:r>
+              <a:rPr sz="1300" b="0">
+                <a:solidFill>
+                  <a:srgbClr val="172F2D"/>
+                </a:solidFill>
+                <a:latin typeface="Aptos"/>
+              </a:rPr>
+              <a:t>Eight inputs: history, categories, BMI, HbA1c, and glucose.</a:t>
+            </a:r>
+          </a:p>
+        </p:txBody>
+      </p:sp>
+      <p:sp>
+        <p:nvSpPr>
+          <p:cNvPr id="12" name="TextBox 11"/>
+          <p:cNvSpPr txBox="1"/>
+          <p:nvPr/>
+        </p:nvSpPr>
+        <p:spPr>
+          <a:xfrm>
+            <a:off x="530352" y="4151376"/>
+            <a:ext cx="164592" cy="219456"/>
+          </a:xfrm>
+          <a:prstGeom prst="rect">
+            <a:avLst/>
+          </a:prstGeom>
+          <a:noFill/>
+        </p:spPr>
+        <p:txBody>
+          <a:bodyPr wrap="none" lIns="18288" rIns="18288" anchor="ctr">
+            <a:spAutoFit/>
+          </a:bodyPr>
+          <a:lstStyle/>
+          <a:p>
+            <a:pPr algn="l"/>
+            <a:r>
+              <a:rPr sz="1600" b="1">
+                <a:solidFill>
+                  <a:srgbClr val="A8443F"/>
+                </a:solidFill>
+                <a:latin typeface="Aptos"/>
+              </a:rPr>
+              <a:t>•</a:t>
+            </a:r>
+          </a:p>
+        </p:txBody>
+      </p:sp>
+      <p:sp>
+        <p:nvSpPr>
+          <p:cNvPr id="13" name="TextBox 12"/>
+          <p:cNvSpPr txBox="1"/>
+          <p:nvPr/>
+        </p:nvSpPr>
+        <p:spPr>
+          <a:xfrm>
+            <a:off x="786384" y="4142232"/>
+            <a:ext cx="3264408" cy="457200"/>
+          </a:xfrm>
+          <a:prstGeom prst="rect">
+            <a:avLst/>
+          </a:prstGeom>
+          <a:noFill/>
+        </p:spPr>
+        <p:txBody>
+          <a:bodyPr wrap="none" lIns="18288" rIns="18288" anchor="ctr">
+            <a:spAutoFit/>
+          </a:bodyPr>
+          <a:lstStyle/>
+          <a:p>
+            <a:pPr algn="l"/>
+            <a:r>
+              <a:rPr sz="1300" b="0">
+                <a:solidFill>
+                  <a:srgbClr val="172F2D"/>
+                </a:solidFill>
+                <a:latin typeface="Aptos"/>
+              </a:rPr>
+              <a:t>The pipeline handles categories, missing values, scale, and extremes.</a:t>
+            </a:r>
+          </a:p>
+        </p:txBody>
+      </p:sp>
+      <p:sp>
+        <p:nvSpPr>
+          <p:cNvPr id="14" name="Rectangle 13"/>
           <p:cNvSpPr/>
           <p:nvPr/>
         </p:nvSpPr>
         <p:spPr>
           <a:xfrm>
-            <a:off x="3950208" y="2295144"/>
-            <a:ext cx="2194560" cy="347472"/>
-          </a:xfrm>
-          <a:prstGeom prst="roundRect">
+            <a:off x="530352" y="5047488"/>
+            <a:ext cx="3337560" cy="658368"/>
+          </a:xfrm>
+          <a:prstGeom prst="rect">
             <a:avLst/>
           </a:prstGeom>
           <a:solidFill>
-            <a:srgbClr val="E7F6F3"/>
+            <a:srgbClr val="123F3B"/>
           </a:solidFill>
-          <a:ln w="8890">
+          <a:ln w="7620">
             <a:solidFill>
-              <a:srgbClr val="DCE5E7"/>
+              <a:srgbClr val="123F3B"/>
             </a:solidFill>
           </a:ln>
         </p:spPr>
@@ -5142,24 +5006,59 @@
       </p:sp>
       <p:sp>
         <p:nvSpPr>
-          <p:cNvPr id="10" name="Rounded Rectangle 9"/>
+          <p:cNvPr id="15" name="TextBox 14"/>
+          <p:cNvSpPr txBox="1"/>
+          <p:nvPr/>
+        </p:nvSpPr>
+        <p:spPr>
+          <a:xfrm>
+            <a:off x="731520" y="5202936"/>
+            <a:ext cx="2907792" cy="329184"/>
+          </a:xfrm>
+          <a:prstGeom prst="rect">
+            <a:avLst/>
+          </a:prstGeom>
+          <a:noFill/>
+        </p:spPr>
+        <p:txBody>
+          <a:bodyPr wrap="none" lIns="18288" rIns="18288" anchor="ctr">
+            <a:spAutoFit/>
+          </a:bodyPr>
+          <a:lstStyle/>
+          <a:p>
+            <a:pPr algn="l"/>
+            <a:r>
+              <a:rPr sz="1200" b="0">
+                <a:solidFill>
+                  <a:srgbClr val="F7FAF5"/>
+                </a:solidFill>
+                <a:latin typeface="Georgia"/>
+              </a:rPr>
+              <a:t>Feature importance describes model reliance. It does not prove cause.</a:t>
+            </a:r>
+          </a:p>
+        </p:txBody>
+      </p:sp>
+      <p:sp>
+        <p:nvSpPr>
+          <p:cNvPr id="16" name="Rectangle 15"/>
           <p:cNvSpPr/>
           <p:nvPr/>
         </p:nvSpPr>
         <p:spPr>
           <a:xfrm>
-            <a:off x="7516368" y="2295144"/>
-            <a:ext cx="2194560" cy="347472"/>
-          </a:xfrm>
-          <a:prstGeom prst="roundRect">
+            <a:off x="4526280" y="945514"/>
+            <a:ext cx="7178040" cy="5012690"/>
+          </a:xfrm>
+          <a:prstGeom prst="rect">
             <a:avLst/>
           </a:prstGeom>
           <a:solidFill>
-            <a:srgbClr val="E7F6F3"/>
+            <a:srgbClr val="F7FAF5"/>
           </a:solidFill>
-          <a:ln w="8890">
+          <a:ln w="7620">
             <a:solidFill>
-              <a:srgbClr val="DCE5E7"/>
+              <a:srgbClr val="B8C5BC"/>
             </a:solidFill>
           </a:ln>
         </p:spPr>
@@ -5185,1568 +5084,30 @@
           </a:p>
         </p:txBody>
       </p:sp>
-      <p:sp>
-        <p:nvSpPr>
-          <p:cNvPr id="11" name="TextBox 10"/>
-          <p:cNvSpPr txBox="1"/>
+      <p:pic>
+        <p:nvPicPr>
+          <p:cNvPr id="17" name="Picture 16" descr="04-understand-the-data.png"/>
+          <p:cNvPicPr>
+            <a:picLocks noChangeAspect="1"/>
+          </p:cNvPicPr>
           <p:nvPr/>
-        </p:nvSpPr>
-        <p:spPr>
-          <a:xfrm>
-            <a:off x="3950208" y="2313432"/>
-            <a:ext cx="2194560" cy="274320"/>
-          </a:xfrm>
-          <a:prstGeom prst="rect">
-            <a:avLst/>
-          </a:prstGeom>
-          <a:noFill/>
-        </p:spPr>
-        <p:txBody>
-          <a:bodyPr wrap="none" lIns="18288" rIns="18288" anchor="ctr">
-            <a:spAutoFit/>
-          </a:bodyPr>
-          <a:lstStyle/>
-          <a:p>
-            <a:pPr algn="ctr"/>
-            <a:r>
-              <a:rPr sz="1300" b="1">
-                <a:solidFill>
-                  <a:srgbClr val="198B83"/>
-                </a:solidFill>
-                <a:latin typeface="Aptos"/>
-              </a:rPr>
-              <a:t>0.972</a:t>
-            </a:r>
-          </a:p>
-        </p:txBody>
-      </p:sp>
-      <p:sp>
-        <p:nvSpPr>
-          <p:cNvPr id="12" name="TextBox 11"/>
-          <p:cNvSpPr txBox="1"/>
-          <p:nvPr/>
-        </p:nvSpPr>
-        <p:spPr>
-          <a:xfrm>
-            <a:off x="7516368" y="2313432"/>
-            <a:ext cx="2194560" cy="274320"/>
-          </a:xfrm>
-          <a:prstGeom prst="rect">
-            <a:avLst/>
-          </a:prstGeom>
-          <a:noFill/>
-        </p:spPr>
-        <p:txBody>
-          <a:bodyPr wrap="none" lIns="18288" rIns="18288" anchor="ctr">
-            <a:spAutoFit/>
-          </a:bodyPr>
-          <a:lstStyle/>
-          <a:p>
-            <a:pPr algn="ctr"/>
-            <a:r>
-              <a:rPr sz="1300" b="1">
-                <a:solidFill>
-                  <a:srgbClr val="198B83"/>
-                </a:solidFill>
-                <a:latin typeface="Aptos"/>
-              </a:rPr>
-              <a:t>0.972</a:t>
-            </a:r>
-          </a:p>
-        </p:txBody>
-      </p:sp>
-      <p:sp>
-        <p:nvSpPr>
-          <p:cNvPr id="13" name="TextBox 12"/>
-          <p:cNvSpPr txBox="1"/>
-          <p:nvPr/>
-        </p:nvSpPr>
-        <p:spPr>
-          <a:xfrm>
-            <a:off x="777240" y="2852927"/>
-            <a:ext cx="2194560" cy="274320"/>
-          </a:xfrm>
-          <a:prstGeom prst="rect">
-            <a:avLst/>
-          </a:prstGeom>
-          <a:noFill/>
-        </p:spPr>
-        <p:txBody>
-          <a:bodyPr wrap="none" lIns="18288" rIns="18288" anchor="ctr">
-            <a:spAutoFit/>
-          </a:bodyPr>
-          <a:lstStyle/>
-          <a:p>
-            <a:pPr algn="l"/>
-            <a:r>
-              <a:rPr sz="1100" b="0">
-                <a:solidFill>
-                  <a:srgbClr val="2C3D48"/>
-                </a:solidFill>
-                <a:latin typeface="Aptos"/>
-              </a:rPr>
-              <a:t>Precision</a:t>
-            </a:r>
-          </a:p>
-        </p:txBody>
-      </p:sp>
-      <p:sp>
-        <p:nvSpPr>
-          <p:cNvPr id="14" name="Rounded Rectangle 13"/>
-          <p:cNvSpPr/>
-          <p:nvPr/>
-        </p:nvSpPr>
-        <p:spPr>
-          <a:xfrm>
-            <a:off x="3950208" y="2816351"/>
-            <a:ext cx="2194560" cy="347472"/>
-          </a:xfrm>
-          <a:prstGeom prst="roundRect">
-            <a:avLst/>
-          </a:prstGeom>
-          <a:solidFill>
-            <a:srgbClr val="E7F6F3"/>
-          </a:solidFill>
-          <a:ln w="8890">
-            <a:solidFill>
-              <a:srgbClr val="DCE5E7"/>
-            </a:solidFill>
-          </a:ln>
-        </p:spPr>
-        <p:style>
-          <a:lnRef idx="1">
-            <a:schemeClr val="accent1"/>
-          </a:lnRef>
-          <a:fillRef idx="3">
-            <a:schemeClr val="accent1"/>
-          </a:fillRef>
-          <a:effectRef idx="2">
-            <a:schemeClr val="accent1"/>
-          </a:effectRef>
-          <a:fontRef idx="minor">
-            <a:schemeClr val="lt1"/>
-          </a:fontRef>
-        </p:style>
-        <p:txBody>
-          <a:bodyPr rtlCol="0" anchor="ctr"/>
-          <a:lstStyle/>
-          <a:p>
-            <a:pPr algn="ctr"/>
-          </a:p>
-        </p:txBody>
-      </p:sp>
-      <p:sp>
-        <p:nvSpPr>
-          <p:cNvPr id="15" name="Rounded Rectangle 14"/>
-          <p:cNvSpPr/>
-          <p:nvPr/>
-        </p:nvSpPr>
-        <p:spPr>
-          <a:xfrm>
-            <a:off x="7516368" y="2816351"/>
-            <a:ext cx="2194560" cy="347472"/>
-          </a:xfrm>
-          <a:prstGeom prst="roundRect">
-            <a:avLst/>
-          </a:prstGeom>
-          <a:solidFill>
-            <a:srgbClr val="E7F6F3"/>
-          </a:solidFill>
-          <a:ln w="8890">
-            <a:solidFill>
-              <a:srgbClr val="DCE5E7"/>
-            </a:solidFill>
-          </a:ln>
-        </p:spPr>
-        <p:style>
-          <a:lnRef idx="1">
-            <a:schemeClr val="accent1"/>
-          </a:lnRef>
-          <a:fillRef idx="3">
-            <a:schemeClr val="accent1"/>
-          </a:fillRef>
-          <a:effectRef idx="2">
-            <a:schemeClr val="accent1"/>
-          </a:effectRef>
-          <a:fontRef idx="minor">
-            <a:schemeClr val="lt1"/>
-          </a:fontRef>
-        </p:style>
-        <p:txBody>
-          <a:bodyPr rtlCol="0" anchor="ctr"/>
-          <a:lstStyle/>
-          <a:p>
-            <a:pPr algn="ctr"/>
-          </a:p>
-        </p:txBody>
-      </p:sp>
-      <p:sp>
-        <p:nvSpPr>
-          <p:cNvPr id="16" name="TextBox 15"/>
-          <p:cNvSpPr txBox="1"/>
-          <p:nvPr/>
-        </p:nvSpPr>
-        <p:spPr>
-          <a:xfrm>
-            <a:off x="3950208" y="2834639"/>
-            <a:ext cx="2194560" cy="274320"/>
-          </a:xfrm>
-          <a:prstGeom prst="rect">
-            <a:avLst/>
-          </a:prstGeom>
-          <a:noFill/>
-        </p:spPr>
-        <p:txBody>
-          <a:bodyPr wrap="none" lIns="18288" rIns="18288" anchor="ctr">
-            <a:spAutoFit/>
-          </a:bodyPr>
-          <a:lstStyle/>
-          <a:p>
-            <a:pPr algn="ctr"/>
-            <a:r>
-              <a:rPr sz="1300" b="1">
-                <a:solidFill>
-                  <a:srgbClr val="198B83"/>
-                </a:solidFill>
-                <a:latin typeface="Aptos"/>
-              </a:rPr>
-              <a:t>1.000</a:t>
-            </a:r>
-          </a:p>
-        </p:txBody>
-      </p:sp>
-      <p:sp>
-        <p:nvSpPr>
-          <p:cNvPr id="17" name="TextBox 16"/>
-          <p:cNvSpPr txBox="1"/>
-          <p:nvPr/>
-        </p:nvSpPr>
-        <p:spPr>
-          <a:xfrm>
-            <a:off x="7516368" y="2834639"/>
-            <a:ext cx="2194560" cy="274320"/>
-          </a:xfrm>
-          <a:prstGeom prst="rect">
-            <a:avLst/>
-          </a:prstGeom>
-          <a:noFill/>
-        </p:spPr>
-        <p:txBody>
-          <a:bodyPr wrap="none" lIns="18288" rIns="18288" anchor="ctr">
-            <a:spAutoFit/>
-          </a:bodyPr>
-          <a:lstStyle/>
-          <a:p>
-            <a:pPr algn="ctr"/>
-            <a:r>
-              <a:rPr sz="1300" b="1">
-                <a:solidFill>
-                  <a:srgbClr val="198B83"/>
-                </a:solidFill>
-                <a:latin typeface="Aptos"/>
-              </a:rPr>
-              <a:t>0.993</a:t>
-            </a:r>
-          </a:p>
-        </p:txBody>
-      </p:sp>
-      <p:sp>
-        <p:nvSpPr>
-          <p:cNvPr id="18" name="TextBox 17"/>
-          <p:cNvSpPr txBox="1"/>
-          <p:nvPr/>
-        </p:nvSpPr>
-        <p:spPr>
-          <a:xfrm>
-            <a:off x="777240" y="3374135"/>
-            <a:ext cx="2194560" cy="274320"/>
-          </a:xfrm>
-          <a:prstGeom prst="rect">
-            <a:avLst/>
-          </a:prstGeom>
-          <a:noFill/>
-        </p:spPr>
-        <p:txBody>
-          <a:bodyPr wrap="none" lIns="18288" rIns="18288" anchor="ctr">
-            <a:spAutoFit/>
-          </a:bodyPr>
-          <a:lstStyle/>
-          <a:p>
-            <a:pPr algn="l"/>
-            <a:r>
-              <a:rPr sz="1100" b="0">
-                <a:solidFill>
-                  <a:srgbClr val="2C3D48"/>
-                </a:solidFill>
-                <a:latin typeface="Aptos"/>
-              </a:rPr>
-              <a:t>Recall</a:t>
-            </a:r>
-          </a:p>
-        </p:txBody>
-      </p:sp>
-      <p:sp>
-        <p:nvSpPr>
-          <p:cNvPr id="19" name="Rounded Rectangle 18"/>
-          <p:cNvSpPr/>
-          <p:nvPr/>
-        </p:nvSpPr>
-        <p:spPr>
-          <a:xfrm>
-            <a:off x="3950208" y="3337559"/>
-            <a:ext cx="2194560" cy="347472"/>
-          </a:xfrm>
-          <a:prstGeom prst="roundRect">
-            <a:avLst/>
-          </a:prstGeom>
-          <a:solidFill>
-            <a:srgbClr val="E7F6F3"/>
-          </a:solidFill>
-          <a:ln w="8890">
-            <a:solidFill>
-              <a:srgbClr val="DCE5E7"/>
-            </a:solidFill>
-          </a:ln>
-        </p:spPr>
-        <p:style>
-          <a:lnRef idx="1">
-            <a:schemeClr val="accent1"/>
-          </a:lnRef>
-          <a:fillRef idx="3">
-            <a:schemeClr val="accent1"/>
-          </a:fillRef>
-          <a:effectRef idx="2">
-            <a:schemeClr val="accent1"/>
-          </a:effectRef>
-          <a:fontRef idx="minor">
-            <a:schemeClr val="lt1"/>
-          </a:fontRef>
-        </p:style>
-        <p:txBody>
-          <a:bodyPr rtlCol="0" anchor="ctr"/>
-          <a:lstStyle/>
-          <a:p>
-            <a:pPr algn="ctr"/>
-          </a:p>
-        </p:txBody>
-      </p:sp>
-      <p:sp>
-        <p:nvSpPr>
-          <p:cNvPr id="20" name="Rounded Rectangle 19"/>
-          <p:cNvSpPr/>
-          <p:nvPr/>
-        </p:nvSpPr>
-        <p:spPr>
-          <a:xfrm>
-            <a:off x="7516368" y="3337559"/>
-            <a:ext cx="2194560" cy="347472"/>
-          </a:xfrm>
-          <a:prstGeom prst="roundRect">
-            <a:avLst/>
-          </a:prstGeom>
-          <a:solidFill>
-            <a:srgbClr val="E7F6F3"/>
-          </a:solidFill>
-          <a:ln w="8890">
-            <a:solidFill>
-              <a:srgbClr val="DCE5E7"/>
-            </a:solidFill>
-          </a:ln>
-        </p:spPr>
-        <p:style>
-          <a:lnRef idx="1">
-            <a:schemeClr val="accent1"/>
-          </a:lnRef>
-          <a:fillRef idx="3">
-            <a:schemeClr val="accent1"/>
-          </a:fillRef>
-          <a:effectRef idx="2">
-            <a:schemeClr val="accent1"/>
-          </a:effectRef>
-          <a:fontRef idx="minor">
-            <a:schemeClr val="lt1"/>
-          </a:fontRef>
-        </p:style>
-        <p:txBody>
-          <a:bodyPr rtlCol="0" anchor="ctr"/>
-          <a:lstStyle/>
-          <a:p>
-            <a:pPr algn="ctr"/>
-          </a:p>
-        </p:txBody>
-      </p:sp>
-      <p:sp>
-        <p:nvSpPr>
-          <p:cNvPr id="21" name="TextBox 20"/>
-          <p:cNvSpPr txBox="1"/>
-          <p:nvPr/>
-        </p:nvSpPr>
-        <p:spPr>
-          <a:xfrm>
-            <a:off x="3950208" y="3355847"/>
-            <a:ext cx="2194560" cy="274320"/>
-          </a:xfrm>
-          <a:prstGeom prst="rect">
-            <a:avLst/>
-          </a:prstGeom>
-          <a:noFill/>
-        </p:spPr>
-        <p:txBody>
-          <a:bodyPr wrap="none" lIns="18288" rIns="18288" anchor="ctr">
-            <a:spAutoFit/>
-          </a:bodyPr>
-          <a:lstStyle/>
-          <a:p>
-            <a:pPr algn="ctr"/>
-            <a:r>
-              <a:rPr sz="1300" b="1">
-                <a:solidFill>
-                  <a:srgbClr val="198B83"/>
-                </a:solidFill>
-                <a:latin typeface="Aptos"/>
-              </a:rPr>
-              <a:t>0.675</a:t>
-            </a:r>
-          </a:p>
-        </p:txBody>
-      </p:sp>
-      <p:sp>
-        <p:nvSpPr>
-          <p:cNvPr id="22" name="TextBox 21"/>
-          <p:cNvSpPr txBox="1"/>
-          <p:nvPr/>
-        </p:nvSpPr>
-        <p:spPr>
-          <a:xfrm>
-            <a:off x="7516368" y="3355847"/>
-            <a:ext cx="2194560" cy="274320"/>
-          </a:xfrm>
-          <a:prstGeom prst="rect">
-            <a:avLst/>
-          </a:prstGeom>
-          <a:noFill/>
-        </p:spPr>
-        <p:txBody>
-          <a:bodyPr wrap="none" lIns="18288" rIns="18288" anchor="ctr">
-            <a:spAutoFit/>
-          </a:bodyPr>
-          <a:lstStyle/>
-          <a:p>
-            <a:pPr algn="ctr"/>
-            <a:r>
-              <a:rPr sz="1300" b="1">
-                <a:solidFill>
-                  <a:srgbClr val="198B83"/>
-                </a:solidFill>
-                <a:latin typeface="Aptos"/>
-              </a:rPr>
-              <a:t>0.679</a:t>
-            </a:r>
-          </a:p>
-        </p:txBody>
-      </p:sp>
-      <p:sp>
-        <p:nvSpPr>
-          <p:cNvPr id="23" name="TextBox 22"/>
-          <p:cNvSpPr txBox="1"/>
-          <p:nvPr/>
-        </p:nvSpPr>
-        <p:spPr>
-          <a:xfrm>
-            <a:off x="777240" y="3895344"/>
-            <a:ext cx="2194560" cy="274320"/>
-          </a:xfrm>
-          <a:prstGeom prst="rect">
-            <a:avLst/>
-          </a:prstGeom>
-          <a:noFill/>
-        </p:spPr>
-        <p:txBody>
-          <a:bodyPr wrap="none" lIns="18288" rIns="18288" anchor="ctr">
-            <a:spAutoFit/>
-          </a:bodyPr>
-          <a:lstStyle/>
-          <a:p>
-            <a:pPr algn="l"/>
-            <a:r>
-              <a:rPr sz="1100" b="0">
-                <a:solidFill>
-                  <a:srgbClr val="2C3D48"/>
-                </a:solidFill>
-                <a:latin typeface="Aptos"/>
-              </a:rPr>
-              <a:t>F1 score</a:t>
-            </a:r>
-          </a:p>
-        </p:txBody>
-      </p:sp>
-      <p:sp>
-        <p:nvSpPr>
-          <p:cNvPr id="24" name="Rounded Rectangle 23"/>
-          <p:cNvSpPr/>
-          <p:nvPr/>
-        </p:nvSpPr>
-        <p:spPr>
-          <a:xfrm>
-            <a:off x="3950208" y="3858768"/>
-            <a:ext cx="2194560" cy="347472"/>
-          </a:xfrm>
-          <a:prstGeom prst="roundRect">
-            <a:avLst/>
-          </a:prstGeom>
-          <a:solidFill>
-            <a:srgbClr val="E7F6F3"/>
-          </a:solidFill>
-          <a:ln w="8890">
-            <a:solidFill>
-              <a:srgbClr val="DCE5E7"/>
-            </a:solidFill>
-          </a:ln>
-        </p:spPr>
-        <p:style>
-          <a:lnRef idx="1">
-            <a:schemeClr val="accent1"/>
-          </a:lnRef>
-          <a:fillRef idx="3">
-            <a:schemeClr val="accent1"/>
-          </a:fillRef>
-          <a:effectRef idx="2">
-            <a:schemeClr val="accent1"/>
-          </a:effectRef>
-          <a:fontRef idx="minor">
-            <a:schemeClr val="lt1"/>
-          </a:fontRef>
-        </p:style>
-        <p:txBody>
-          <a:bodyPr rtlCol="0" anchor="ctr"/>
-          <a:lstStyle/>
-          <a:p>
-            <a:pPr algn="ctr"/>
-          </a:p>
-        </p:txBody>
-      </p:sp>
-      <p:sp>
-        <p:nvSpPr>
-          <p:cNvPr id="25" name="Rounded Rectangle 24"/>
-          <p:cNvSpPr/>
-          <p:nvPr/>
-        </p:nvSpPr>
-        <p:spPr>
-          <a:xfrm>
-            <a:off x="7516368" y="3858768"/>
-            <a:ext cx="2194560" cy="347472"/>
-          </a:xfrm>
-          <a:prstGeom prst="roundRect">
-            <a:avLst/>
-          </a:prstGeom>
-          <a:solidFill>
-            <a:srgbClr val="E7F6F3"/>
-          </a:solidFill>
-          <a:ln w="8890">
-            <a:solidFill>
-              <a:srgbClr val="DCE5E7"/>
-            </a:solidFill>
-          </a:ln>
-        </p:spPr>
-        <p:style>
-          <a:lnRef idx="1">
-            <a:schemeClr val="accent1"/>
-          </a:lnRef>
-          <a:fillRef idx="3">
-            <a:schemeClr val="accent1"/>
-          </a:fillRef>
-          <a:effectRef idx="2">
-            <a:schemeClr val="accent1"/>
-          </a:effectRef>
-          <a:fontRef idx="minor">
-            <a:schemeClr val="lt1"/>
-          </a:fontRef>
-        </p:style>
-        <p:txBody>
-          <a:bodyPr rtlCol="0" anchor="ctr"/>
-          <a:lstStyle/>
-          <a:p>
-            <a:pPr algn="ctr"/>
-          </a:p>
-        </p:txBody>
-      </p:sp>
-      <p:sp>
-        <p:nvSpPr>
-          <p:cNvPr id="26" name="TextBox 25"/>
-          <p:cNvSpPr txBox="1"/>
-          <p:nvPr/>
-        </p:nvSpPr>
-        <p:spPr>
-          <a:xfrm>
-            <a:off x="3950208" y="3877056"/>
-            <a:ext cx="2194560" cy="274320"/>
-          </a:xfrm>
-          <a:prstGeom prst="rect">
-            <a:avLst/>
-          </a:prstGeom>
-          <a:noFill/>
-        </p:spPr>
-        <p:txBody>
-          <a:bodyPr wrap="none" lIns="18288" rIns="18288" anchor="ctr">
-            <a:spAutoFit/>
-          </a:bodyPr>
-          <a:lstStyle/>
-          <a:p>
-            <a:pPr algn="ctr"/>
-            <a:r>
-              <a:rPr sz="1300" b="1">
-                <a:solidFill>
-                  <a:srgbClr val="198B83"/>
-                </a:solidFill>
-                <a:latin typeface="Aptos"/>
-              </a:rPr>
-              <a:t>0.806</a:t>
-            </a:r>
-          </a:p>
-        </p:txBody>
-      </p:sp>
-      <p:sp>
-        <p:nvSpPr>
-          <p:cNvPr id="27" name="TextBox 26"/>
-          <p:cNvSpPr txBox="1"/>
-          <p:nvPr/>
-        </p:nvSpPr>
-        <p:spPr>
-          <a:xfrm>
-            <a:off x="7516368" y="3877056"/>
-            <a:ext cx="2194560" cy="274320"/>
-          </a:xfrm>
-          <a:prstGeom prst="rect">
-            <a:avLst/>
-          </a:prstGeom>
-          <a:noFill/>
-        </p:spPr>
-        <p:txBody>
-          <a:bodyPr wrap="none" lIns="18288" rIns="18288" anchor="ctr">
-            <a:spAutoFit/>
-          </a:bodyPr>
-          <a:lstStyle/>
-          <a:p>
-            <a:pPr algn="ctr"/>
-            <a:r>
-              <a:rPr sz="1300" b="1">
-                <a:solidFill>
-                  <a:srgbClr val="198B83"/>
-                </a:solidFill>
-                <a:latin typeface="Aptos"/>
-              </a:rPr>
-              <a:t>0.806</a:t>
-            </a:r>
-          </a:p>
-        </p:txBody>
-      </p:sp>
-      <p:sp>
-        <p:nvSpPr>
-          <p:cNvPr id="28" name="TextBox 27"/>
-          <p:cNvSpPr txBox="1"/>
-          <p:nvPr/>
-        </p:nvSpPr>
-        <p:spPr>
-          <a:xfrm>
-            <a:off x="777240" y="4416552"/>
-            <a:ext cx="2194560" cy="274320"/>
-          </a:xfrm>
-          <a:prstGeom prst="rect">
-            <a:avLst/>
-          </a:prstGeom>
-          <a:noFill/>
-        </p:spPr>
-        <p:txBody>
-          <a:bodyPr wrap="none" lIns="18288" rIns="18288" anchor="ctr">
-            <a:spAutoFit/>
-          </a:bodyPr>
-          <a:lstStyle/>
-          <a:p>
-            <a:pPr algn="l"/>
-            <a:r>
-              <a:rPr sz="1100" b="1">
-                <a:solidFill>
-                  <a:srgbClr val="2C3D48"/>
-                </a:solidFill>
-                <a:latin typeface="Aptos"/>
-              </a:rPr>
-              <a:t>ROC-AUC</a:t>
-            </a:r>
-          </a:p>
-        </p:txBody>
-      </p:sp>
-      <p:sp>
-        <p:nvSpPr>
-          <p:cNvPr id="29" name="Rounded Rectangle 28"/>
-          <p:cNvSpPr/>
-          <p:nvPr/>
-        </p:nvSpPr>
-        <p:spPr>
-          <a:xfrm>
-            <a:off x="3950208" y="4379976"/>
-            <a:ext cx="2194560" cy="347472"/>
-          </a:xfrm>
-          <a:prstGeom prst="roundRect">
-            <a:avLst/>
-          </a:prstGeom>
-          <a:solidFill>
-            <a:srgbClr val="E7F6F3"/>
-          </a:solidFill>
-          <a:ln w="8890">
-            <a:solidFill>
-              <a:srgbClr val="DCE5E7"/>
-            </a:solidFill>
-          </a:ln>
-        </p:spPr>
-        <p:style>
-          <a:lnRef idx="1">
-            <a:schemeClr val="accent1"/>
-          </a:lnRef>
-          <a:fillRef idx="3">
-            <a:schemeClr val="accent1"/>
-          </a:fillRef>
-          <a:effectRef idx="2">
-            <a:schemeClr val="accent1"/>
-          </a:effectRef>
-          <a:fontRef idx="minor">
-            <a:schemeClr val="lt1"/>
-          </a:fontRef>
-        </p:style>
-        <p:txBody>
-          <a:bodyPr rtlCol="0" anchor="ctr"/>
-          <a:lstStyle/>
-          <a:p>
-            <a:pPr algn="ctr"/>
-          </a:p>
-        </p:txBody>
-      </p:sp>
-      <p:sp>
-        <p:nvSpPr>
-          <p:cNvPr id="30" name="Rounded Rectangle 29"/>
-          <p:cNvSpPr/>
-          <p:nvPr/>
-        </p:nvSpPr>
-        <p:spPr>
-          <a:xfrm>
-            <a:off x="7516368" y="4379976"/>
-            <a:ext cx="2194560" cy="347472"/>
-          </a:xfrm>
-          <a:prstGeom prst="roundRect">
-            <a:avLst/>
-          </a:prstGeom>
-          <a:solidFill>
-            <a:srgbClr val="E7F6F3"/>
-          </a:solidFill>
-          <a:ln w="8890">
-            <a:solidFill>
-              <a:srgbClr val="DCE5E7"/>
-            </a:solidFill>
-          </a:ln>
-        </p:spPr>
-        <p:style>
-          <a:lnRef idx="1">
-            <a:schemeClr val="accent1"/>
-          </a:lnRef>
-          <a:fillRef idx="3">
-            <a:schemeClr val="accent1"/>
-          </a:fillRef>
-          <a:effectRef idx="2">
-            <a:schemeClr val="accent1"/>
-          </a:effectRef>
-          <a:fontRef idx="minor">
-            <a:schemeClr val="lt1"/>
-          </a:fontRef>
-        </p:style>
-        <p:txBody>
-          <a:bodyPr rtlCol="0" anchor="ctr"/>
-          <a:lstStyle/>
-          <a:p>
-            <a:pPr algn="ctr"/>
-          </a:p>
-        </p:txBody>
-      </p:sp>
-      <p:sp>
-        <p:nvSpPr>
-          <p:cNvPr id="31" name="TextBox 30"/>
-          <p:cNvSpPr txBox="1"/>
-          <p:nvPr/>
-        </p:nvSpPr>
-        <p:spPr>
-          <a:xfrm>
-            <a:off x="3950208" y="4398264"/>
-            <a:ext cx="2194560" cy="274320"/>
-          </a:xfrm>
-          <a:prstGeom prst="rect">
-            <a:avLst/>
-          </a:prstGeom>
-          <a:noFill/>
-        </p:spPr>
-        <p:txBody>
-          <a:bodyPr wrap="none" lIns="18288" rIns="18288" anchor="ctr">
-            <a:spAutoFit/>
-          </a:bodyPr>
-          <a:lstStyle/>
-          <a:p>
-            <a:pPr algn="ctr"/>
-            <a:r>
-              <a:rPr sz="1300" b="1">
-                <a:solidFill>
-                  <a:srgbClr val="198B83"/>
-                </a:solidFill>
-                <a:latin typeface="Aptos"/>
-              </a:rPr>
-              <a:t>0.976</a:t>
-            </a:r>
-          </a:p>
-        </p:txBody>
-      </p:sp>
-      <p:sp>
-        <p:nvSpPr>
-          <p:cNvPr id="32" name="TextBox 31"/>
-          <p:cNvSpPr txBox="1"/>
-          <p:nvPr/>
-        </p:nvSpPr>
-        <p:spPr>
-          <a:xfrm>
-            <a:off x="7516368" y="4398264"/>
-            <a:ext cx="2194560" cy="274320"/>
-          </a:xfrm>
-          <a:prstGeom prst="rect">
-            <a:avLst/>
-          </a:prstGeom>
-          <a:noFill/>
-        </p:spPr>
-        <p:txBody>
-          <a:bodyPr wrap="none" lIns="18288" rIns="18288" anchor="ctr">
-            <a:spAutoFit/>
-          </a:bodyPr>
-          <a:lstStyle/>
-          <a:p>
-            <a:pPr algn="ctr"/>
-            <a:r>
-              <a:rPr sz="1300" b="1">
-                <a:solidFill>
-                  <a:srgbClr val="198B83"/>
-                </a:solidFill>
-                <a:latin typeface="Aptos"/>
-              </a:rPr>
-              <a:t>0.979</a:t>
-            </a:r>
-          </a:p>
-        </p:txBody>
-      </p:sp>
-      <p:sp>
-        <p:nvSpPr>
-          <p:cNvPr id="33" name="Rounded Rectangle 32"/>
-          <p:cNvSpPr/>
-          <p:nvPr/>
-        </p:nvSpPr>
-        <p:spPr>
-          <a:xfrm>
-            <a:off x="777240" y="5166360"/>
-            <a:ext cx="10012680" cy="603504"/>
-          </a:xfrm>
-          <a:prstGeom prst="roundRect">
-            <a:avLst/>
-          </a:prstGeom>
-          <a:solidFill>
-            <a:srgbClr val="E7F6F3"/>
-          </a:solidFill>
-          <a:ln w="8890">
-            <a:solidFill>
-              <a:srgbClr val="E7F6F3"/>
-            </a:solidFill>
-          </a:ln>
-        </p:spPr>
-        <p:style>
-          <a:lnRef idx="1">
-            <a:schemeClr val="accent1"/>
-          </a:lnRef>
-          <a:fillRef idx="3">
-            <a:schemeClr val="accent1"/>
-          </a:fillRef>
-          <a:effectRef idx="2">
-            <a:schemeClr val="accent1"/>
-          </a:effectRef>
-          <a:fontRef idx="minor">
-            <a:schemeClr val="lt1"/>
-          </a:fontRef>
-        </p:style>
-        <p:txBody>
-          <a:bodyPr rtlCol="0" anchor="ctr"/>
-          <a:lstStyle/>
-          <a:p>
-            <a:pPr algn="ctr"/>
-          </a:p>
-        </p:txBody>
-      </p:sp>
-      <p:sp>
-        <p:nvSpPr>
-          <p:cNvPr id="34" name="TextBox 33"/>
-          <p:cNvSpPr txBox="1"/>
-          <p:nvPr/>
-        </p:nvSpPr>
-        <p:spPr>
-          <a:xfrm>
-            <a:off x="987552" y="5340096"/>
-            <a:ext cx="9509760" cy="228600"/>
-          </a:xfrm>
-          <a:prstGeom prst="rect">
-            <a:avLst/>
-          </a:prstGeom>
-          <a:noFill/>
-        </p:spPr>
-        <p:txBody>
-          <a:bodyPr wrap="none" lIns="18288" rIns="18288" anchor="ctr">
-            <a:spAutoFit/>
-          </a:bodyPr>
-          <a:lstStyle/>
-          <a:p>
-            <a:pPr algn="l"/>
-            <a:r>
-              <a:rPr sz="1000" b="1">
-                <a:solidFill>
-                  <a:srgbClr val="2C3D48"/>
-                </a:solidFill>
-                <a:latin typeface="Aptos"/>
-              </a:rPr>
-              <a:t>Use ROC-AUC and F1 alongside recall to justify the model selected for the final demo.</a:t>
-            </a:r>
-          </a:p>
-        </p:txBody>
-      </p:sp>
-      <p:sp>
-        <p:nvSpPr>
-          <p:cNvPr id="35" name="TextBox 34"/>
-          <p:cNvSpPr txBox="1"/>
-          <p:nvPr/>
-        </p:nvSpPr>
-        <p:spPr>
-          <a:xfrm>
-            <a:off x="502920" y="6473952"/>
-            <a:ext cx="5029200" cy="228600"/>
-          </a:xfrm>
-          <a:prstGeom prst="rect">
-            <a:avLst/>
-          </a:prstGeom>
-          <a:noFill/>
-        </p:spPr>
-        <p:txBody>
-          <a:bodyPr wrap="none" lIns="18288" rIns="18288" anchor="ctr">
-            <a:spAutoFit/>
-          </a:bodyPr>
-          <a:lstStyle/>
-          <a:p>
-            <a:pPr algn="l"/>
-            <a:r>
-              <a:rPr sz="700" b="1">
-                <a:solidFill>
-                  <a:srgbClr val="6F7E88"/>
-                </a:solidFill>
-                <a:latin typeface="Aptos"/>
-              </a:rPr>
-              <a:t>DIABETES ENSEMBLE LAB  •  MINI-PROJECT</a:t>
-            </a:r>
-          </a:p>
-        </p:txBody>
-      </p:sp>
-      <p:sp>
-        <p:nvSpPr>
-          <p:cNvPr id="36" name="TextBox 35"/>
-          <p:cNvSpPr txBox="1"/>
-          <p:nvPr/>
-        </p:nvSpPr>
-        <p:spPr>
-          <a:xfrm>
-            <a:off x="10881360" y="6473952"/>
-            <a:ext cx="777240" cy="228600"/>
-          </a:xfrm>
-          <a:prstGeom prst="rect">
-            <a:avLst/>
-          </a:prstGeom>
-          <a:noFill/>
-        </p:spPr>
-        <p:txBody>
-          <a:bodyPr wrap="none" lIns="18288" rIns="18288" anchor="ctr">
-            <a:spAutoFit/>
-          </a:bodyPr>
-          <a:lstStyle/>
-          <a:p>
-            <a:pPr algn="r"/>
-            <a:r>
-              <a:rPr sz="700" b="1">
-                <a:solidFill>
-                  <a:srgbClr val="6F7E88"/>
-                </a:solidFill>
-                <a:latin typeface="Aptos"/>
-              </a:rPr>
-              <a:t>03 / 04</a:t>
-            </a:r>
-          </a:p>
-        </p:txBody>
-      </p:sp>
-    </p:spTree>
-  </p:cSld>
-  <p:clrMapOvr>
-    <a:masterClrMapping/>
-  </p:clrMapOvr>
-</p:sld>
-</file>
-
-<file path=ppt/slides/slide4.xml><?xml version="1.0" encoding="utf-8"?>
-<p:sld xmlns:a="http://schemas.openxmlformats.org/drawingml/2006/main" xmlns:p="http://schemas.openxmlformats.org/presentationml/2006/main" xmlns:r="http://schemas.openxmlformats.org/officeDocument/2006/relationships">
-  <p:cSld>
-    <p:bg>
-      <p:bgPr>
-        <a:solidFill>
-          <a:srgbClr val="172D3A"/>
-        </a:solidFill>
-        <a:effectLst/>
-      </p:bgPr>
-    </p:bg>
-    <p:spTree>
-      <p:nvGrpSpPr>
-        <p:cNvPr id="1" name=""/>
-        <p:cNvGrpSpPr/>
-        <p:nvPr/>
-      </p:nvGrpSpPr>
-      <p:grpSpPr/>
-      <p:sp>
-        <p:nvSpPr>
-          <p:cNvPr id="2" name="TextBox 1"/>
-          <p:cNvSpPr txBox="1"/>
-          <p:nvPr/>
-        </p:nvSpPr>
-        <p:spPr>
-          <a:xfrm>
-            <a:off x="594360" y="475488"/>
-            <a:ext cx="4114800" cy="228600"/>
-          </a:xfrm>
-          <a:prstGeom prst="rect">
-            <a:avLst/>
-          </a:prstGeom>
-          <a:noFill/>
-        </p:spPr>
-        <p:txBody>
-          <a:bodyPr wrap="none" lIns="18288" rIns="18288" anchor="ctr">
-            <a:spAutoFit/>
-          </a:bodyPr>
-          <a:lstStyle/>
-          <a:p>
-            <a:pPr algn="l"/>
-            <a:r>
-              <a:rPr sz="900" b="1">
-                <a:solidFill>
-                  <a:srgbClr val="E7F6F3"/>
-                </a:solidFill>
-                <a:latin typeface="Aptos"/>
-              </a:rPr>
-              <a:t>03  /  INTERPRETATION</a:t>
-            </a:r>
-          </a:p>
-        </p:txBody>
-      </p:sp>
-      <p:sp>
-        <p:nvSpPr>
-          <p:cNvPr id="3" name="TextBox 2"/>
-          <p:cNvSpPr txBox="1"/>
-          <p:nvPr/>
-        </p:nvSpPr>
-        <p:spPr>
-          <a:xfrm>
-            <a:off x="594360" y="914400"/>
-            <a:ext cx="6583680" cy="1143000"/>
-          </a:xfrm>
-          <a:prstGeom prst="rect">
-            <a:avLst/>
-          </a:prstGeom>
-          <a:noFill/>
-        </p:spPr>
-        <p:txBody>
-          <a:bodyPr wrap="none" lIns="18288" rIns="18288" anchor="ctr">
-            <a:spAutoFit/>
-          </a:bodyPr>
-          <a:lstStyle/>
-          <a:p>
-            <a:pPr algn="l"/>
-            <a:r>
-              <a:rPr sz="2500" b="1">
-                <a:solidFill>
-                  <a:srgbClr val="FFFFFF"/>
-                </a:solidFill>
-                <a:latin typeface="Aptos"/>
-              </a:rPr>
-              <a:t>The best model is the one
-that fits the decision.</a:t>
-            </a:r>
-          </a:p>
-        </p:txBody>
-      </p:sp>
-      <p:sp>
-        <p:nvSpPr>
-          <p:cNvPr id="4" name="TextBox 3"/>
-          <p:cNvSpPr txBox="1"/>
-          <p:nvPr/>
-        </p:nvSpPr>
-        <p:spPr>
-          <a:xfrm>
-            <a:off x="685800" y="2514600"/>
-            <a:ext cx="365760" cy="274320"/>
-          </a:xfrm>
-          <a:prstGeom prst="rect">
-            <a:avLst/>
-          </a:prstGeom>
-          <a:noFill/>
-        </p:spPr>
-        <p:txBody>
-          <a:bodyPr wrap="none" lIns="18288" rIns="18288" anchor="ctr">
-            <a:spAutoFit/>
-          </a:bodyPr>
-          <a:lstStyle/>
-          <a:p>
-            <a:pPr algn="l"/>
-            <a:r>
-              <a:rPr sz="1000" b="1">
-                <a:solidFill>
-                  <a:srgbClr val="EF7C63"/>
-                </a:solidFill>
-                <a:latin typeface="Aptos"/>
-              </a:rPr>
-              <a:t>01</a:t>
-            </a:r>
-          </a:p>
-        </p:txBody>
-      </p:sp>
-      <p:sp>
-        <p:nvSpPr>
-          <p:cNvPr id="5" name="TextBox 4"/>
-          <p:cNvSpPr txBox="1"/>
-          <p:nvPr/>
-        </p:nvSpPr>
-        <p:spPr>
-          <a:xfrm>
-            <a:off x="1325880" y="2514600"/>
-            <a:ext cx="2743200" cy="274320"/>
-          </a:xfrm>
-          <a:prstGeom prst="rect">
-            <a:avLst/>
-          </a:prstGeom>
-          <a:noFill/>
-        </p:spPr>
-        <p:txBody>
-          <a:bodyPr wrap="none" lIns="18288" rIns="18288" anchor="ctr">
-            <a:spAutoFit/>
-          </a:bodyPr>
-          <a:lstStyle/>
-          <a:p>
-            <a:pPr algn="l"/>
-            <a:r>
-              <a:rPr sz="1200" b="1">
-                <a:solidFill>
-                  <a:srgbClr val="FFFFFF"/>
-                </a:solidFill>
-                <a:latin typeface="Aptos"/>
-              </a:rPr>
-              <a:t>Read the trade-off</a:t>
-            </a:r>
-          </a:p>
-        </p:txBody>
-      </p:sp>
-      <p:sp>
-        <p:nvSpPr>
-          <p:cNvPr id="6" name="TextBox 5"/>
-          <p:cNvSpPr txBox="1"/>
-          <p:nvPr/>
-        </p:nvSpPr>
-        <p:spPr>
-          <a:xfrm>
-            <a:off x="3749039" y="2514600"/>
-            <a:ext cx="7132320" cy="457200"/>
-          </a:xfrm>
-          <a:prstGeom prst="rect">
-            <a:avLst/>
-          </a:prstGeom>
-          <a:noFill/>
-        </p:spPr>
-        <p:txBody>
-          <a:bodyPr wrap="none" lIns="18288" rIns="18288" anchor="ctr">
-            <a:spAutoFit/>
-          </a:bodyPr>
-          <a:lstStyle/>
-          <a:p>
-            <a:pPr algn="l"/>
-            <a:r>
-              <a:rPr sz="1000" b="0">
-                <a:solidFill>
-                  <a:srgbClr val="E7F6F3"/>
-                </a:solidFill>
-                <a:latin typeface="Aptos"/>
-              </a:rPr>
-              <a:t>Recall protects against missed positive cases; precision limits unnecessary alarms.</a:t>
-            </a:r>
-          </a:p>
-        </p:txBody>
-      </p:sp>
-      <p:sp>
-        <p:nvSpPr>
-          <p:cNvPr id="7" name="TextBox 6"/>
-          <p:cNvSpPr txBox="1"/>
-          <p:nvPr/>
-        </p:nvSpPr>
-        <p:spPr>
-          <a:xfrm>
-            <a:off x="685800" y="3429000"/>
-            <a:ext cx="365760" cy="274320"/>
-          </a:xfrm>
-          <a:prstGeom prst="rect">
-            <a:avLst/>
-          </a:prstGeom>
-          <a:noFill/>
-        </p:spPr>
-        <p:txBody>
-          <a:bodyPr wrap="none" lIns="18288" rIns="18288" anchor="ctr">
-            <a:spAutoFit/>
-          </a:bodyPr>
-          <a:lstStyle/>
-          <a:p>
-            <a:pPr algn="l"/>
-            <a:r>
-              <a:rPr sz="1000" b="1">
-                <a:solidFill>
-                  <a:srgbClr val="EF7C63"/>
-                </a:solidFill>
-                <a:latin typeface="Aptos"/>
-              </a:rPr>
-              <a:t>02</a:t>
-            </a:r>
-          </a:p>
-        </p:txBody>
-      </p:sp>
-      <p:sp>
-        <p:nvSpPr>
-          <p:cNvPr id="8" name="TextBox 7"/>
-          <p:cNvSpPr txBox="1"/>
-          <p:nvPr/>
-        </p:nvSpPr>
-        <p:spPr>
-          <a:xfrm>
-            <a:off x="1325880" y="3429000"/>
-            <a:ext cx="2743200" cy="274320"/>
-          </a:xfrm>
-          <a:prstGeom prst="rect">
-            <a:avLst/>
-          </a:prstGeom>
-          <a:noFill/>
-        </p:spPr>
-        <p:txBody>
-          <a:bodyPr wrap="none" lIns="18288" rIns="18288" anchor="ctr">
-            <a:spAutoFit/>
-          </a:bodyPr>
-          <a:lstStyle/>
-          <a:p>
-            <a:pPr algn="l"/>
-            <a:r>
-              <a:rPr sz="1200" b="1">
-                <a:solidFill>
-                  <a:srgbClr val="FFFFFF"/>
-                </a:solidFill>
-                <a:latin typeface="Aptos"/>
-              </a:rPr>
-              <a:t>Explain the signals</a:t>
-            </a:r>
-          </a:p>
-        </p:txBody>
-      </p:sp>
-      <p:sp>
-        <p:nvSpPr>
-          <p:cNvPr id="9" name="TextBox 8"/>
-          <p:cNvSpPr txBox="1"/>
-          <p:nvPr/>
-        </p:nvSpPr>
-        <p:spPr>
-          <a:xfrm>
-            <a:off x="3749039" y="3429000"/>
-            <a:ext cx="7132320" cy="457200"/>
-          </a:xfrm>
-          <a:prstGeom prst="rect">
-            <a:avLst/>
-          </a:prstGeom>
-          <a:noFill/>
-        </p:spPr>
-        <p:txBody>
-          <a:bodyPr wrap="none" lIns="18288" rIns="18288" anchor="ctr">
-            <a:spAutoFit/>
-          </a:bodyPr>
-          <a:lstStyle/>
-          <a:p>
-            <a:pPr algn="l"/>
-            <a:r>
-              <a:rPr sz="1000" b="0">
-                <a:solidFill>
-                  <a:srgbClr val="E7F6F3"/>
-                </a:solidFill>
-                <a:latin typeface="Aptos"/>
-              </a:rPr>
-              <a:t>Feature importance shows model reliance, not causation. Discuss glucose, HbA1c, BMI, and context.</a:t>
-            </a:r>
-          </a:p>
-        </p:txBody>
-      </p:sp>
-      <p:sp>
-        <p:nvSpPr>
-          <p:cNvPr id="10" name="TextBox 9"/>
-          <p:cNvSpPr txBox="1"/>
-          <p:nvPr/>
-        </p:nvSpPr>
-        <p:spPr>
-          <a:xfrm>
-            <a:off x="685800" y="4343400"/>
-            <a:ext cx="365760" cy="274320"/>
-          </a:xfrm>
-          <a:prstGeom prst="rect">
-            <a:avLst/>
-          </a:prstGeom>
-          <a:noFill/>
-        </p:spPr>
-        <p:txBody>
-          <a:bodyPr wrap="none" lIns="18288" rIns="18288" anchor="ctr">
-            <a:spAutoFit/>
-          </a:bodyPr>
-          <a:lstStyle/>
-          <a:p>
-            <a:pPr algn="l"/>
-            <a:r>
-              <a:rPr sz="1000" b="1">
-                <a:solidFill>
-                  <a:srgbClr val="EF7C63"/>
-                </a:solidFill>
-                <a:latin typeface="Aptos"/>
-              </a:rPr>
-              <a:t>03</a:t>
-            </a:r>
-          </a:p>
-        </p:txBody>
-      </p:sp>
-      <p:sp>
-        <p:nvSpPr>
-          <p:cNvPr id="11" name="TextBox 10"/>
-          <p:cNvSpPr txBox="1"/>
-          <p:nvPr/>
-        </p:nvSpPr>
-        <p:spPr>
-          <a:xfrm>
-            <a:off x="1325880" y="4343400"/>
-            <a:ext cx="2743200" cy="274320"/>
-          </a:xfrm>
-          <a:prstGeom prst="rect">
-            <a:avLst/>
-          </a:prstGeom>
-          <a:noFill/>
-        </p:spPr>
-        <p:txBody>
-          <a:bodyPr wrap="none" lIns="18288" rIns="18288" anchor="ctr">
-            <a:spAutoFit/>
-          </a:bodyPr>
-          <a:lstStyle/>
-          <a:p>
-            <a:pPr algn="l"/>
-            <a:r>
-              <a:rPr sz="1200" b="1">
-                <a:solidFill>
-                  <a:srgbClr val="FFFFFF"/>
-                </a:solidFill>
-                <a:latin typeface="Aptos"/>
-              </a:rPr>
-              <a:t>Keep the boundary clear</a:t>
-            </a:r>
-          </a:p>
-        </p:txBody>
-      </p:sp>
-      <p:sp>
-        <p:nvSpPr>
-          <p:cNvPr id="12" name="TextBox 11"/>
-          <p:cNvSpPr txBox="1"/>
-          <p:nvPr/>
-        </p:nvSpPr>
-        <p:spPr>
-          <a:xfrm>
-            <a:off x="3749039" y="4343400"/>
-            <a:ext cx="7132320" cy="457200"/>
-          </a:xfrm>
-          <a:prstGeom prst="rect">
-            <a:avLst/>
-          </a:prstGeom>
-          <a:noFill/>
-        </p:spPr>
-        <p:txBody>
-          <a:bodyPr wrap="none" lIns="18288" rIns="18288" anchor="ctr">
-            <a:spAutoFit/>
-          </a:bodyPr>
-          <a:lstStyle/>
-          <a:p>
-            <a:pPr algn="l"/>
-            <a:r>
-              <a:rPr sz="1000" b="0">
-                <a:solidFill>
-                  <a:srgbClr val="E7F6F3"/>
-                </a:solidFill>
-                <a:latin typeface="Aptos"/>
-              </a:rPr>
-              <a:t>A benchmark probability supports analysis. It is not a clinical diagnosis.</a:t>
-            </a:r>
-          </a:p>
-        </p:txBody>
-      </p:sp>
-      <p:sp>
-        <p:nvSpPr>
-          <p:cNvPr id="13" name="Rounded Rectangle 12"/>
-          <p:cNvSpPr/>
-          <p:nvPr/>
-        </p:nvSpPr>
-        <p:spPr>
-          <a:xfrm>
-            <a:off x="640080" y="5486400"/>
-            <a:ext cx="10698480" cy="512064"/>
-          </a:xfrm>
-          <a:prstGeom prst="roundRect">
-            <a:avLst/>
-          </a:prstGeom>
-          <a:solidFill>
-            <a:srgbClr val="198B83"/>
-          </a:solidFill>
-          <a:ln w="8890">
-            <a:solidFill>
-              <a:srgbClr val="198B83"/>
-            </a:solidFill>
-          </a:ln>
-        </p:spPr>
-        <p:style>
-          <a:lnRef idx="1">
-            <a:schemeClr val="accent1"/>
-          </a:lnRef>
-          <a:fillRef idx="3">
-            <a:schemeClr val="accent1"/>
-          </a:fillRef>
-          <a:effectRef idx="2">
-            <a:schemeClr val="accent1"/>
-          </a:effectRef>
-          <a:fontRef idx="minor">
-            <a:schemeClr val="lt1"/>
-          </a:fontRef>
-        </p:style>
-        <p:txBody>
-          <a:bodyPr rtlCol="0" anchor="ctr"/>
-          <a:lstStyle/>
-          <a:p>
-            <a:pPr algn="ctr"/>
-          </a:p>
-        </p:txBody>
-      </p:sp>
-      <p:sp>
-        <p:nvSpPr>
-          <p:cNvPr id="14" name="TextBox 13"/>
-          <p:cNvSpPr txBox="1"/>
-          <p:nvPr/>
-        </p:nvSpPr>
-        <p:spPr>
-          <a:xfrm>
-            <a:off x="868680" y="5632704"/>
-            <a:ext cx="10241280" cy="219456"/>
-          </a:xfrm>
-          <a:prstGeom prst="rect">
-            <a:avLst/>
-          </a:prstGeom>
-          <a:noFill/>
-        </p:spPr>
-        <p:txBody>
-          <a:bodyPr wrap="none" lIns="18288" rIns="18288" anchor="ctr">
-            <a:spAutoFit/>
-          </a:bodyPr>
-          <a:lstStyle/>
-          <a:p>
-            <a:pPr algn="ctr"/>
-            <a:r>
-              <a:rPr sz="1000" b="1">
-                <a:solidFill>
-                  <a:srgbClr val="FFFFFF"/>
-                </a:solidFill>
-                <a:latin typeface="Aptos"/>
-              </a:rPr>
-              <a:t>Notebook  •  tuned artifacts  •  Vercel UI  •  reproducible comparison</a:t>
-            </a:r>
-          </a:p>
-        </p:txBody>
-      </p:sp>
-      <p:sp>
-        <p:nvSpPr>
-          <p:cNvPr id="15" name="TextBox 14"/>
-          <p:cNvSpPr txBox="1"/>
-          <p:nvPr/>
-        </p:nvSpPr>
-        <p:spPr>
-          <a:xfrm>
-            <a:off x="502920" y="6473952"/>
-            <a:ext cx="5029200" cy="228600"/>
-          </a:xfrm>
-          <a:prstGeom prst="rect">
-            <a:avLst/>
-          </a:prstGeom>
-          <a:noFill/>
-        </p:spPr>
-        <p:txBody>
-          <a:bodyPr wrap="none" lIns="18288" rIns="18288" anchor="ctr">
-            <a:spAutoFit/>
-          </a:bodyPr>
-          <a:lstStyle/>
-          <a:p>
-            <a:pPr algn="l"/>
-            <a:r>
-              <a:rPr sz="700" b="1">
-                <a:solidFill>
-                  <a:srgbClr val="6F7E88"/>
-                </a:solidFill>
-                <a:latin typeface="Aptos"/>
-              </a:rPr>
-              <a:t>DIABETES ENSEMBLE LAB  •  MINI-PROJECT</a:t>
-            </a:r>
-          </a:p>
-        </p:txBody>
-      </p:sp>
-      <p:sp>
-        <p:nvSpPr>
-          <p:cNvPr id="16" name="TextBox 15"/>
-          <p:cNvSpPr txBox="1"/>
-          <p:nvPr/>
-        </p:nvSpPr>
-        <p:spPr>
-          <a:xfrm>
-            <a:off x="10881360" y="6473952"/>
-            <a:ext cx="777240" cy="228600"/>
-          </a:xfrm>
-          <a:prstGeom prst="rect">
-            <a:avLst/>
-          </a:prstGeom>
-          <a:noFill/>
-        </p:spPr>
-        <p:txBody>
-          <a:bodyPr wrap="none" lIns="18288" rIns="18288" anchor="ctr">
-            <a:spAutoFit/>
-          </a:bodyPr>
-          <a:lstStyle/>
-          <a:p>
-            <a:pPr algn="r"/>
-            <a:r>
-              <a:rPr sz="700" b="1">
-                <a:solidFill>
-                  <a:srgbClr val="6F7E88"/>
-                </a:solidFill>
-                <a:latin typeface="Aptos"/>
-              </a:rPr>
-              <a:t>04 / 04</a:t>
-            </a:r>
-          </a:p>
-        </p:txBody>
-      </p:sp>
+        </p:nvPicPr>
+        <p:blipFill>
+          <a:blip r:embed="rId2"/>
+          <a:stretch>
+            <a:fillRect/>
+          </a:stretch>
+        </p:blipFill>
+        <p:spPr>
+          <a:xfrm>
+            <a:off x="4572000" y="991234"/>
+            <a:ext cx="7086600" cy="4921250"/>
+          </a:xfrm>
+          <a:prstGeom prst="rect">
+            <a:avLst/>
+          </a:prstGeom>
+        </p:spPr>
+      </p:pic>
     </p:spTree>
   </p:cSld>
   <p:clrMapOvr>

</xml_diff>